<commit_message>
Add Jan 28 meeting materials and ROI presentation
- Meeting agenda (markdown, Word doc, PowerPoint)
- PublicHealth ROI overview slides for CAPHE members
- Slide generation scripts for future use
- Update events.json with Tim Brown March presentation

Co-Authored-By: Claude Opus 4.5 <noreply@anthropic.com>
</commit_message>
<xml_diff>
--- a/outputs/presentations/CAPHE_Meeting_2026-01-28.pptx
+++ b/outputs/presentations/CAPHE_Meeting_2026-01-28.pptx
@@ -9,6 +9,11 @@
     <p:sldId id="257" r:id="rId8"/>
     <p:sldId id="258" r:id="rId9"/>
     <p:sldId id="259" r:id="rId10"/>
+    <p:sldId id="260" r:id="rId11"/>
+    <p:sldId id="261" r:id="rId12"/>
+    <p:sldId id="262" r:id="rId13"/>
+    <p:sldId id="263" r:id="rId14"/>
+    <p:sldId id="264" r:id="rId15"/>
   </p:sldIdLst>
   <p:sldSz cx="12191695" cy="6858000" type="screen4x3"/>
   <p:notesSz cx="6858000" cy="9144000"/>
@@ -3194,7 +3199,7 @@
           <a:noFill/>
         </p:spPr>
         <p:txBody>
-          <a:bodyPr wrap="square">
+          <a:bodyPr wrap="none">
             <a:spAutoFit/>
           </a:bodyPr>
           <a:lstStyle/>
@@ -3212,9 +3217,6 @@
           </a:p>
           <a:p>
             <a:pPr algn="ctr">
-              <a:spcBef>
-                <a:spcPts val="1000"/>
-              </a:spcBef>
               <a:defRPr sz="2400">
                 <a:solidFill>
                   <a:srgbClr val="1C1C1C"/>
@@ -3244,7 +3246,7 @@
           <a:noFill/>
         </p:spPr>
         <p:txBody>
-          <a:bodyPr wrap="square">
+          <a:bodyPr wrap="none">
             <a:spAutoFit/>
           </a:bodyPr>
           <a:lstStyle/>
@@ -3262,9 +3264,6 @@
           </a:p>
           <a:p>
             <a:pPr algn="ctr">
-              <a:spcBef>
-                <a:spcPts val="1500"/>
-              </a:spcBef>
               <a:defRPr sz="2800">
                 <a:solidFill>
                   <a:srgbClr val="1C1C1C"/>
@@ -3424,8 +3423,8 @@
         </p:nvSpPr>
         <p:spPr>
           <a:xfrm>
-            <a:off x="914400" y="1600200"/>
-            <a:ext cx="10362895" cy="4572000"/>
+            <a:off x="914400" y="1371600"/>
+            <a:ext cx="10362895" cy="5029200"/>
           </a:xfrm>
           <a:prstGeom prst="rect">
             <a:avLst/>
@@ -3440,61 +3439,151 @@
           <a:p>
             <a:pPr>
               <a:spcAft>
-                <a:spcPts val="2000"/>
+                <a:spcPts val="800"/>
               </a:spcAft>
-              <a:defRPr sz="2800">
+              <a:defRPr sz="2400" b="0">
                 <a:solidFill>
                   <a:srgbClr val="1C1C1C"/>
                 </a:solidFill>
               </a:defRPr>
             </a:pPr>
             <a:r>
-              <a:t>1.  Welcome &amp; Announcements</a:t>
+              <a:t>1.  New Website Demo</a:t>
             </a:r>
           </a:p>
           <a:p>
             <a:pPr>
               <a:spcAft>
-                <a:spcPts val="2000"/>
+                <a:spcPts val="800"/>
               </a:spcAft>
-              <a:defRPr sz="2800">
+              <a:defRPr sz="2400" b="0">
                 <a:solidFill>
                   <a:srgbClr val="1C1C1C"/>
                 </a:solidFill>
               </a:defRPr>
             </a:pPr>
             <a:r>
-              <a:t>2.  Open Discussion / Networking</a:t>
+              <a:t>2.  Methods Lab Overview &amp; New Lab Ideas</a:t>
             </a:r>
           </a:p>
           <a:p>
             <a:pPr>
               <a:spcAft>
-                <a:spcPts val="2000"/>
+                <a:spcPts val="800"/>
               </a:spcAft>
-              <a:defRPr sz="2800">
+              <a:defRPr sz="2400" b="1">
+                <a:solidFill>
+                  <a:srgbClr val="003080"/>
+                </a:solidFill>
+              </a:defRPr>
+            </a:pPr>
+            <a:r>
+              <a:t>3.  Announcements</a:t>
+            </a:r>
+          </a:p>
+          <a:p>
+            <a:pPr>
+              <a:spcAft>
+                <a:spcPts val="800"/>
+              </a:spcAft>
+              <a:defRPr sz="2000" b="0">
                 <a:solidFill>
                   <a:srgbClr val="1C1C1C"/>
                 </a:solidFill>
               </a:defRPr>
             </a:pPr>
             <a:r>
-              <a:t>3.  Upcoming Events</a:t>
+              <a:t>   • Feb 12 Webinar: Introduction to Health Economics</a:t>
             </a:r>
           </a:p>
           <a:p>
             <a:pPr>
               <a:spcAft>
-                <a:spcPts val="2000"/>
+                <a:spcPts val="800"/>
               </a:spcAft>
-              <a:defRPr sz="2800">
+              <a:defRPr sz="2000" b="0">
                 <a:solidFill>
                   <a:srgbClr val="1C1C1C"/>
                 </a:solidFill>
               </a:defRPr>
             </a:pPr>
             <a:r>
-              <a:t>4.  Q&amp;A / Wrap-up</a:t>
+              <a:t>   • March 25: Tim Brown on Public Health ROI</a:t>
+            </a:r>
+          </a:p>
+          <a:p>
+            <a:pPr>
+              <a:spcAft>
+                <a:spcPts val="800"/>
+              </a:spcAft>
+              <a:defRPr sz="2000" b="0">
+                <a:solidFill>
+                  <a:srgbClr val="1C1C1C"/>
+                </a:solidFill>
+              </a:defRPr>
+            </a:pPr>
+            <a:r>
+              <a:t>   • Webinar topic ideas for fall</a:t>
+            </a:r>
+          </a:p>
+          <a:p>
+            <a:pPr>
+              <a:spcAft>
+                <a:spcPts val="800"/>
+              </a:spcAft>
+              <a:defRPr sz="2400" b="1">
+                <a:solidFill>
+                  <a:srgbClr val="003080"/>
+                </a:solidFill>
+              </a:defRPr>
+            </a:pPr>
+            <a:r>
+              <a:t>4.  Organization Business</a:t>
+            </a:r>
+          </a:p>
+          <a:p>
+            <a:pPr>
+              <a:spcAft>
+                <a:spcPts val="800"/>
+              </a:spcAft>
+              <a:defRPr sz="2000" b="0">
+                <a:solidFill>
+                  <a:srgbClr val="1C1C1C"/>
+                </a:solidFill>
+              </a:defRPr>
+            </a:pPr>
+            <a:r>
+              <a:t>   • Governance docs for review</a:t>
+            </a:r>
+          </a:p>
+          <a:p>
+            <a:pPr>
+              <a:spcAft>
+                <a:spcPts val="800"/>
+              </a:spcAft>
+              <a:defRPr sz="2000" b="0">
+                <a:solidFill>
+                  <a:srgbClr val="1C1C1C"/>
+                </a:solidFill>
+              </a:defRPr>
+            </a:pPr>
+            <a:r>
+              <a:t>   • Letter to Erika Pan</a:t>
+            </a:r>
+          </a:p>
+          <a:p>
+            <a:pPr>
+              <a:spcAft>
+                <a:spcPts val="800"/>
+              </a:spcAft>
+              <a:defRPr sz="2400" b="0">
+                <a:solidFill>
+                  <a:srgbClr val="1C1C1C"/>
+                </a:solidFill>
+              </a:defRPr>
+            </a:pPr>
+            <a:r>
+              <a:t>5.  Open Discussion &amp; Next Steps</a:t>
             </a:r>
           </a:p>
         </p:txBody>
@@ -3526,7 +3615,7 @@
         <p:spPr>
           <a:xfrm>
             <a:off x="0" y="0"/>
-            <a:ext cx="12191695" cy="137160"/>
+            <a:ext cx="12191695" cy="1371600"/>
           </a:xfrm>
           <a:prstGeom prst="rect">
             <a:avLst/>
@@ -3568,8 +3657,8 @@
         </p:nvSpPr>
         <p:spPr>
           <a:xfrm>
-            <a:off x="685800" y="457200"/>
-            <a:ext cx="10820095" cy="914400"/>
+            <a:off x="685800" y="320040"/>
+            <a:ext cx="10820095" cy="457200"/>
           </a:xfrm>
           <a:prstGeom prst="rect">
             <a:avLst/>
@@ -3583,71 +3672,28 @@
           <a:lstStyle/>
           <a:p>
             <a:pPr>
-              <a:defRPr sz="4000" b="1">
-                <a:solidFill>
-                  <a:srgbClr val="003080"/>
-                </a:solidFill>
-              </a:defRPr>
-            </a:pPr>
-            <a:r>
-              <a:t>Upcoming Events</a:t>
-            </a:r>
-          </a:p>
-        </p:txBody>
-      </p:sp>
-      <p:sp>
-        <p:nvSpPr>
-          <p:cNvPr id="4" name="Rectangle 3"/>
-          <p:cNvSpPr/>
-          <p:nvPr/>
-        </p:nvSpPr>
-        <p:spPr>
-          <a:xfrm>
-            <a:off x="685800" y="1600200"/>
-            <a:ext cx="1371600" cy="822960"/>
-          </a:xfrm>
-          <a:prstGeom prst="rect">
-            <a:avLst/>
-          </a:prstGeom>
-          <a:solidFill>
-            <a:srgbClr val="003080"/>
-          </a:solidFill>
-          <a:ln>
-            <a:noFill/>
-          </a:ln>
-        </p:spPr>
-        <p:style>
-          <a:lnRef idx="1">
-            <a:schemeClr val="accent1"/>
-          </a:lnRef>
-          <a:fillRef idx="3">
-            <a:schemeClr val="accent1"/>
-          </a:fillRef>
-          <a:effectRef idx="2">
-            <a:schemeClr val="accent1"/>
-          </a:effectRef>
-          <a:fontRef idx="minor">
-            <a:schemeClr val="lt1"/>
-          </a:fontRef>
-        </p:style>
-        <p:txBody>
-          <a:bodyPr rtlCol="0" anchor="ctr"/>
-          <a:lstStyle/>
-          <a:p>
-            <a:pPr algn="ctr"/>
-          </a:p>
-        </p:txBody>
-      </p:sp>
-      <p:sp>
-        <p:nvSpPr>
-          <p:cNvPr id="5" name="TextBox 4"/>
+              <a:defRPr sz="1400" b="1">
+                <a:solidFill>
+                  <a:srgbClr val="DA770D"/>
+                </a:solidFill>
+              </a:defRPr>
+            </a:pPr>
+            <a:r>
+              <a:t>DEMO</a:t>
+            </a:r>
+          </a:p>
+        </p:txBody>
+      </p:sp>
+      <p:sp>
+        <p:nvSpPr>
+          <p:cNvPr id="4" name="TextBox 3"/>
           <p:cNvSpPr txBox="1"/>
           <p:nvPr/>
         </p:nvSpPr>
         <p:spPr>
           <a:xfrm>
-            <a:off x="685800" y="1691640"/>
-            <a:ext cx="1371600" cy="640080"/>
+            <a:off x="685800" y="685800"/>
+            <a:ext cx="10820095" cy="685800"/>
           </a:xfrm>
           <a:prstGeom prst="rect">
             <a:avLst/>
@@ -3660,41 +3706,29 @@
           </a:bodyPr>
           <a:lstStyle/>
           <a:p>
-            <a:pPr algn="ctr">
-              <a:defRPr sz="1400" b="1">
+            <a:pPr>
+              <a:defRPr sz="3600" b="1">
                 <a:solidFill>
                   <a:srgbClr val="FFFFFF"/>
                 </a:solidFill>
               </a:defRPr>
             </a:pPr>
             <a:r>
-              <a:t>JAN</a:t>
-            </a:r>
-          </a:p>
-          <a:p>
-            <a:pPr algn="ctr">
-              <a:defRPr sz="2800" b="1">
-                <a:solidFill>
-                  <a:srgbClr val="FFFFFF"/>
-                </a:solidFill>
-              </a:defRPr>
-            </a:pPr>
-            <a:r>
-              <a:t>28</a:t>
-            </a:r>
-          </a:p>
-        </p:txBody>
-      </p:sp>
-      <p:sp>
-        <p:nvSpPr>
-          <p:cNvPr id="6" name="TextBox 5"/>
+              <a:t>New Website: caphegroup.org</a:t>
+            </a:r>
+          </a:p>
+        </p:txBody>
+      </p:sp>
+      <p:sp>
+        <p:nvSpPr>
+          <p:cNvPr id="5" name="TextBox 4"/>
           <p:cNvSpPr txBox="1"/>
           <p:nvPr/>
         </p:nvSpPr>
         <p:spPr>
           <a:xfrm>
-            <a:off x="2286000" y="1600200"/>
-            <a:ext cx="8991295" cy="822960"/>
+            <a:off x="685800" y="1828800"/>
+            <a:ext cx="5029200" cy="4572000"/>
           </a:xfrm>
           <a:prstGeom prst="rect">
             <a:avLst/>
@@ -3708,95 +3742,148 @@
           <a:lstStyle/>
           <a:p>
             <a:pPr>
-              <a:defRPr sz="1200" b="1">
-                <a:solidFill>
-                  <a:srgbClr val="DA770D"/>
-                </a:solidFill>
-              </a:defRPr>
-            </a:pPr>
-            <a:r>
-              <a:t>Peer Review</a:t>
-            </a:r>
-          </a:p>
-          <a:p>
-            <a:pPr>
+              <a:spcAft>
+                <a:spcPts val="600"/>
+              </a:spcAft>
               <a:defRPr sz="2200" b="1">
                 <a:solidFill>
+                  <a:srgbClr val="003080"/>
+                </a:solidFill>
+              </a:defRPr>
+            </a:pPr>
+            <a:r>
+              <a:t>Public Pages</a:t>
+            </a:r>
+          </a:p>
+          <a:p>
+            <a:pPr>
+              <a:spcAft>
+                <a:spcPts val="600"/>
+              </a:spcAft>
+              <a:defRPr sz="1800" b="0">
+                <a:solidFill>
                   <a:srgbClr val="1C1C1C"/>
                 </a:solidFill>
               </a:defRPr>
             </a:pPr>
             <a:r>
-              <a:t>Monthly Peer Review Session</a:t>
-            </a:r>
-          </a:p>
-          <a:p>
-            <a:pPr>
-              <a:defRPr sz="1400">
-                <a:solidFill>
-                  <a:srgbClr val="424242"/>
-                </a:solidFill>
-              </a:defRPr>
-            </a:pPr>
-            <a:r>
-              <a:t>12:00 PM - 1:00 PM PT</a:t>
-            </a:r>
-          </a:p>
-        </p:txBody>
-      </p:sp>
-      <p:sp>
-        <p:nvSpPr>
-          <p:cNvPr id="7" name="Rectangle 6"/>
-          <p:cNvSpPr/>
-          <p:nvPr/>
-        </p:nvSpPr>
-        <p:spPr>
-          <a:xfrm>
-            <a:off x="685800" y="2606040"/>
-            <a:ext cx="1371600" cy="822960"/>
-          </a:xfrm>
-          <a:prstGeom prst="rect">
-            <a:avLst/>
-          </a:prstGeom>
-          <a:solidFill>
-            <a:srgbClr val="003080"/>
-          </a:solidFill>
-          <a:ln>
-            <a:noFill/>
-          </a:ln>
-        </p:spPr>
-        <p:style>
-          <a:lnRef idx="1">
-            <a:schemeClr val="accent1"/>
-          </a:lnRef>
-          <a:fillRef idx="3">
-            <a:schemeClr val="accent1"/>
-          </a:fillRef>
-          <a:effectRef idx="2">
-            <a:schemeClr val="accent1"/>
-          </a:effectRef>
-          <a:fontRef idx="minor">
-            <a:schemeClr val="lt1"/>
-          </a:fontRef>
-        </p:style>
-        <p:txBody>
-          <a:bodyPr rtlCol="0" anchor="ctr"/>
-          <a:lstStyle/>
-          <a:p>
-            <a:pPr algn="ctr"/>
-          </a:p>
-        </p:txBody>
-      </p:sp>
-      <p:sp>
-        <p:nvSpPr>
-          <p:cNvPr id="8" name="TextBox 7"/>
+              <a:t>   • Programs &amp; webinars</a:t>
+            </a:r>
+          </a:p>
+          <a:p>
+            <a:pPr>
+              <a:spcAft>
+                <a:spcPts val="600"/>
+              </a:spcAft>
+              <a:defRPr sz="1800" b="0">
+                <a:solidFill>
+                  <a:srgbClr val="1C1C1C"/>
+                </a:solidFill>
+              </a:defRPr>
+            </a:pPr>
+            <a:r>
+              <a:t>   • Methods Lab (35 interactive labs!)</a:t>
+            </a:r>
+          </a:p>
+          <a:p>
+            <a:pPr>
+              <a:spcAft>
+                <a:spcPts val="600"/>
+              </a:spcAft>
+              <a:defRPr sz="1800" b="0">
+                <a:solidFill>
+                  <a:srgbClr val="1C1C1C"/>
+                </a:solidFill>
+              </a:defRPr>
+            </a:pPr>
+            <a:r>
+              <a:t>   • Membership information</a:t>
+            </a:r>
+          </a:p>
+          <a:p>
+            <a:pPr>
+              <a:spcAft>
+                <a:spcPts val="600"/>
+              </a:spcAft>
+              <a:defRPr sz="1800" b="0">
+                <a:solidFill>
+                  <a:srgbClr val="1C1C1C"/>
+                </a:solidFill>
+              </a:defRPr>
+            </a:pPr>
+          </a:p>
+          <a:p>
+            <a:pPr>
+              <a:spcAft>
+                <a:spcPts val="600"/>
+              </a:spcAft>
+              <a:defRPr sz="2200" b="1">
+                <a:solidFill>
+                  <a:srgbClr val="003080"/>
+                </a:solidFill>
+              </a:defRPr>
+            </a:pPr>
+            <a:r>
+              <a:t>Member Portal</a:t>
+            </a:r>
+          </a:p>
+          <a:p>
+            <a:pPr>
+              <a:spcAft>
+                <a:spcPts val="600"/>
+              </a:spcAft>
+              <a:defRPr sz="1800" b="0">
+                <a:solidFill>
+                  <a:srgbClr val="1C1C1C"/>
+                </a:solidFill>
+              </a:defRPr>
+            </a:pPr>
+            <a:r>
+              <a:t>   • Meeting recordings</a:t>
+            </a:r>
+          </a:p>
+          <a:p>
+            <a:pPr>
+              <a:spcAft>
+                <a:spcPts val="600"/>
+              </a:spcAft>
+              <a:defRPr sz="1800" b="0">
+                <a:solidFill>
+                  <a:srgbClr val="1C1C1C"/>
+                </a:solidFill>
+              </a:defRPr>
+            </a:pPr>
+            <a:r>
+              <a:t>   • Shared documents</a:t>
+            </a:r>
+          </a:p>
+          <a:p>
+            <a:pPr>
+              <a:spcAft>
+                <a:spcPts val="600"/>
+              </a:spcAft>
+              <a:defRPr sz="1800" b="0">
+                <a:solidFill>
+                  <a:srgbClr val="1C1C1C"/>
+                </a:solidFill>
+              </a:defRPr>
+            </a:pPr>
+            <a:r>
+              <a:t>   • Peer review signup</a:t>
+            </a:r>
+          </a:p>
+        </p:txBody>
+      </p:sp>
+      <p:sp>
+        <p:nvSpPr>
+          <p:cNvPr id="6" name="TextBox 5"/>
           <p:cNvSpPr txBox="1"/>
           <p:nvPr/>
         </p:nvSpPr>
         <p:spPr>
           <a:xfrm>
-            <a:off x="685800" y="2697480"/>
-            <a:ext cx="1371600" cy="640080"/>
+            <a:off x="6400800" y="3200400"/>
+            <a:ext cx="5029200" cy="1371600"/>
           </a:xfrm>
           <a:prstGeom prst="rect">
             <a:avLst/>
@@ -3810,532 +3897,14 @@
           <a:lstStyle/>
           <a:p>
             <a:pPr algn="ctr">
-              <a:defRPr sz="1400" b="1">
-                <a:solidFill>
-                  <a:srgbClr val="FFFFFF"/>
-                </a:solidFill>
-              </a:defRPr>
-            </a:pPr>
-            <a:r>
-              <a:t>FEB</a:t>
-            </a:r>
-          </a:p>
-          <a:p>
-            <a:pPr algn="ctr">
-              <a:defRPr sz="2800" b="1">
-                <a:solidFill>
-                  <a:srgbClr val="FFFFFF"/>
-                </a:solidFill>
-              </a:defRPr>
-            </a:pPr>
-            <a:r>
-              <a:t>12</a:t>
-            </a:r>
-          </a:p>
-        </p:txBody>
-      </p:sp>
-      <p:sp>
-        <p:nvSpPr>
-          <p:cNvPr id="9" name="TextBox 8"/>
-          <p:cNvSpPr txBox="1"/>
-          <p:nvPr/>
-        </p:nvSpPr>
-        <p:spPr>
-          <a:xfrm>
-            <a:off x="2286000" y="2606040"/>
-            <a:ext cx="8991295" cy="822960"/>
-          </a:xfrm>
-          <a:prstGeom prst="rect">
-            <a:avLst/>
-          </a:prstGeom>
-          <a:noFill/>
-        </p:spPr>
-        <p:txBody>
-          <a:bodyPr wrap="square">
-            <a:spAutoFit/>
-          </a:bodyPr>
-          <a:lstStyle/>
-          <a:p>
-            <a:pPr>
-              <a:defRPr sz="1200" b="1">
+              <a:defRPr sz="3600" b="1">
                 <a:solidFill>
                   <a:srgbClr val="DA770D"/>
                 </a:solidFill>
               </a:defRPr>
             </a:pPr>
             <a:r>
-              <a:t>Webinar (Free)</a:t>
-            </a:r>
-          </a:p>
-          <a:p>
-            <a:pPr>
-              <a:defRPr sz="2200" b="1">
-                <a:solidFill>
-                  <a:srgbClr val="1C1C1C"/>
-                </a:solidFill>
-              </a:defRPr>
-            </a:pPr>
-            <a:r>
-              <a:t>Introduction to Health Economics</a:t>
-            </a:r>
-          </a:p>
-          <a:p>
-            <a:pPr>
-              <a:defRPr sz="1400">
-                <a:solidFill>
-                  <a:srgbClr val="424242"/>
-                </a:solidFill>
-              </a:defRPr>
-            </a:pPr>
-            <a:r>
-              <a:t>12:00 PM - 1:00 PM PT</a:t>
-            </a:r>
-          </a:p>
-        </p:txBody>
-      </p:sp>
-      <p:sp>
-        <p:nvSpPr>
-          <p:cNvPr id="10" name="Rectangle 9"/>
-          <p:cNvSpPr/>
-          <p:nvPr/>
-        </p:nvSpPr>
-        <p:spPr>
-          <a:xfrm>
-            <a:off x="685800" y="3611880"/>
-            <a:ext cx="1371600" cy="822960"/>
-          </a:xfrm>
-          <a:prstGeom prst="rect">
-            <a:avLst/>
-          </a:prstGeom>
-          <a:solidFill>
-            <a:srgbClr val="003080"/>
-          </a:solidFill>
-          <a:ln>
-            <a:noFill/>
-          </a:ln>
-        </p:spPr>
-        <p:style>
-          <a:lnRef idx="1">
-            <a:schemeClr val="accent1"/>
-          </a:lnRef>
-          <a:fillRef idx="3">
-            <a:schemeClr val="accent1"/>
-          </a:fillRef>
-          <a:effectRef idx="2">
-            <a:schemeClr val="accent1"/>
-          </a:effectRef>
-          <a:fontRef idx="minor">
-            <a:schemeClr val="lt1"/>
-          </a:fontRef>
-        </p:style>
-        <p:txBody>
-          <a:bodyPr rtlCol="0" anchor="ctr"/>
-          <a:lstStyle/>
-          <a:p>
-            <a:pPr algn="ctr"/>
-          </a:p>
-        </p:txBody>
-      </p:sp>
-      <p:sp>
-        <p:nvSpPr>
-          <p:cNvPr id="11" name="TextBox 10"/>
-          <p:cNvSpPr txBox="1"/>
-          <p:nvPr/>
-        </p:nvSpPr>
-        <p:spPr>
-          <a:xfrm>
-            <a:off x="685800" y="3703320"/>
-            <a:ext cx="1371600" cy="640080"/>
-          </a:xfrm>
-          <a:prstGeom prst="rect">
-            <a:avLst/>
-          </a:prstGeom>
-          <a:noFill/>
-        </p:spPr>
-        <p:txBody>
-          <a:bodyPr wrap="none">
-            <a:spAutoFit/>
-          </a:bodyPr>
-          <a:lstStyle/>
-          <a:p>
-            <a:pPr algn="ctr">
-              <a:defRPr sz="1400" b="1">
-                <a:solidFill>
-                  <a:srgbClr val="FFFFFF"/>
-                </a:solidFill>
-              </a:defRPr>
-            </a:pPr>
-            <a:r>
-              <a:t>FEB</a:t>
-            </a:r>
-          </a:p>
-          <a:p>
-            <a:pPr algn="ctr">
-              <a:defRPr sz="2800" b="1">
-                <a:solidFill>
-                  <a:srgbClr val="FFFFFF"/>
-                </a:solidFill>
-              </a:defRPr>
-            </a:pPr>
-            <a:r>
-              <a:t>25</a:t>
-            </a:r>
-          </a:p>
-        </p:txBody>
-      </p:sp>
-      <p:sp>
-        <p:nvSpPr>
-          <p:cNvPr id="12" name="TextBox 11"/>
-          <p:cNvSpPr txBox="1"/>
-          <p:nvPr/>
-        </p:nvSpPr>
-        <p:spPr>
-          <a:xfrm>
-            <a:off x="2286000" y="3611880"/>
-            <a:ext cx="8991295" cy="822960"/>
-          </a:xfrm>
-          <a:prstGeom prst="rect">
-            <a:avLst/>
-          </a:prstGeom>
-          <a:noFill/>
-        </p:spPr>
-        <p:txBody>
-          <a:bodyPr wrap="square">
-            <a:spAutoFit/>
-          </a:bodyPr>
-          <a:lstStyle/>
-          <a:p>
-            <a:pPr>
-              <a:defRPr sz="1200" b="1">
-                <a:solidFill>
-                  <a:srgbClr val="DA770D"/>
-                </a:solidFill>
-              </a:defRPr>
-            </a:pPr>
-            <a:r>
-              <a:t>Peer Review</a:t>
-            </a:r>
-          </a:p>
-          <a:p>
-            <a:pPr>
-              <a:defRPr sz="2200" b="1">
-                <a:solidFill>
-                  <a:srgbClr val="1C1C1C"/>
-                </a:solidFill>
-              </a:defRPr>
-            </a:pPr>
-            <a:r>
-              <a:t>Monthly Peer Review Session</a:t>
-            </a:r>
-          </a:p>
-          <a:p>
-            <a:pPr>
-              <a:defRPr sz="1400">
-                <a:solidFill>
-                  <a:srgbClr val="424242"/>
-                </a:solidFill>
-              </a:defRPr>
-            </a:pPr>
-            <a:r>
-              <a:t>12:00 PM - 1:00 PM PT</a:t>
-            </a:r>
-          </a:p>
-        </p:txBody>
-      </p:sp>
-      <p:sp>
-        <p:nvSpPr>
-          <p:cNvPr id="13" name="Rectangle 12"/>
-          <p:cNvSpPr/>
-          <p:nvPr/>
-        </p:nvSpPr>
-        <p:spPr>
-          <a:xfrm>
-            <a:off x="685800" y="4617720"/>
-            <a:ext cx="1371600" cy="822960"/>
-          </a:xfrm>
-          <a:prstGeom prst="rect">
-            <a:avLst/>
-          </a:prstGeom>
-          <a:solidFill>
-            <a:srgbClr val="003080"/>
-          </a:solidFill>
-          <a:ln>
-            <a:noFill/>
-          </a:ln>
-        </p:spPr>
-        <p:style>
-          <a:lnRef idx="1">
-            <a:schemeClr val="accent1"/>
-          </a:lnRef>
-          <a:fillRef idx="3">
-            <a:schemeClr val="accent1"/>
-          </a:fillRef>
-          <a:effectRef idx="2">
-            <a:schemeClr val="accent1"/>
-          </a:effectRef>
-          <a:fontRef idx="minor">
-            <a:schemeClr val="lt1"/>
-          </a:fontRef>
-        </p:style>
-        <p:txBody>
-          <a:bodyPr rtlCol="0" anchor="ctr"/>
-          <a:lstStyle/>
-          <a:p>
-            <a:pPr algn="ctr"/>
-          </a:p>
-        </p:txBody>
-      </p:sp>
-      <p:sp>
-        <p:nvSpPr>
-          <p:cNvPr id="14" name="TextBox 13"/>
-          <p:cNvSpPr txBox="1"/>
-          <p:nvPr/>
-        </p:nvSpPr>
-        <p:spPr>
-          <a:xfrm>
-            <a:off x="685800" y="4709160"/>
-            <a:ext cx="1371600" cy="640080"/>
-          </a:xfrm>
-          <a:prstGeom prst="rect">
-            <a:avLst/>
-          </a:prstGeom>
-          <a:noFill/>
-        </p:spPr>
-        <p:txBody>
-          <a:bodyPr wrap="none">
-            <a:spAutoFit/>
-          </a:bodyPr>
-          <a:lstStyle/>
-          <a:p>
-            <a:pPr algn="ctr">
-              <a:defRPr sz="1400" b="1">
-                <a:solidFill>
-                  <a:srgbClr val="FFFFFF"/>
-                </a:solidFill>
-              </a:defRPr>
-            </a:pPr>
-            <a:r>
-              <a:t>MAR</a:t>
-            </a:r>
-          </a:p>
-          <a:p>
-            <a:pPr algn="ctr">
-              <a:defRPr sz="2800" b="1">
-                <a:solidFill>
-                  <a:srgbClr val="FFFFFF"/>
-                </a:solidFill>
-              </a:defRPr>
-            </a:pPr>
-            <a:r>
-              <a:t>25</a:t>
-            </a:r>
-          </a:p>
-        </p:txBody>
-      </p:sp>
-      <p:sp>
-        <p:nvSpPr>
-          <p:cNvPr id="15" name="TextBox 14"/>
-          <p:cNvSpPr txBox="1"/>
-          <p:nvPr/>
-        </p:nvSpPr>
-        <p:spPr>
-          <a:xfrm>
-            <a:off x="2286000" y="4617720"/>
-            <a:ext cx="8991295" cy="822960"/>
-          </a:xfrm>
-          <a:prstGeom prst="rect">
-            <a:avLst/>
-          </a:prstGeom>
-          <a:noFill/>
-        </p:spPr>
-        <p:txBody>
-          <a:bodyPr wrap="square">
-            <a:spAutoFit/>
-          </a:bodyPr>
-          <a:lstStyle/>
-          <a:p>
-            <a:pPr>
-              <a:defRPr sz="1200" b="1">
-                <a:solidFill>
-                  <a:srgbClr val="DA770D"/>
-                </a:solidFill>
-              </a:defRPr>
-            </a:pPr>
-            <a:r>
-              <a:t>Peer Review</a:t>
-            </a:r>
-          </a:p>
-          <a:p>
-            <a:pPr>
-              <a:defRPr sz="2200" b="1">
-                <a:solidFill>
-                  <a:srgbClr val="1C1C1C"/>
-                </a:solidFill>
-              </a:defRPr>
-            </a:pPr>
-            <a:r>
-              <a:t>Monthly Peer Review Session</a:t>
-            </a:r>
-          </a:p>
-          <a:p>
-            <a:pPr>
-              <a:defRPr sz="1400">
-                <a:solidFill>
-                  <a:srgbClr val="424242"/>
-                </a:solidFill>
-              </a:defRPr>
-            </a:pPr>
-            <a:r>
-              <a:t>12:00 PM - 1:00 PM PT</a:t>
-            </a:r>
-          </a:p>
-        </p:txBody>
-      </p:sp>
-      <p:sp>
-        <p:nvSpPr>
-          <p:cNvPr id="16" name="Rectangle 15"/>
-          <p:cNvSpPr/>
-          <p:nvPr/>
-        </p:nvSpPr>
-        <p:spPr>
-          <a:xfrm>
-            <a:off x="685800" y="5623560"/>
-            <a:ext cx="1371600" cy="822960"/>
-          </a:xfrm>
-          <a:prstGeom prst="rect">
-            <a:avLst/>
-          </a:prstGeom>
-          <a:solidFill>
-            <a:srgbClr val="003080"/>
-          </a:solidFill>
-          <a:ln>
-            <a:noFill/>
-          </a:ln>
-        </p:spPr>
-        <p:style>
-          <a:lnRef idx="1">
-            <a:schemeClr val="accent1"/>
-          </a:lnRef>
-          <a:fillRef idx="3">
-            <a:schemeClr val="accent1"/>
-          </a:fillRef>
-          <a:effectRef idx="2">
-            <a:schemeClr val="accent1"/>
-          </a:effectRef>
-          <a:fontRef idx="minor">
-            <a:schemeClr val="lt1"/>
-          </a:fontRef>
-        </p:style>
-        <p:txBody>
-          <a:bodyPr rtlCol="0" anchor="ctr"/>
-          <a:lstStyle/>
-          <a:p>
-            <a:pPr algn="ctr"/>
-          </a:p>
-        </p:txBody>
-      </p:sp>
-      <p:sp>
-        <p:nvSpPr>
-          <p:cNvPr id="17" name="TextBox 16"/>
-          <p:cNvSpPr txBox="1"/>
-          <p:nvPr/>
-        </p:nvSpPr>
-        <p:spPr>
-          <a:xfrm>
-            <a:off x="685800" y="5715000"/>
-            <a:ext cx="1371600" cy="640080"/>
-          </a:xfrm>
-          <a:prstGeom prst="rect">
-            <a:avLst/>
-          </a:prstGeom>
-          <a:noFill/>
-        </p:spPr>
-        <p:txBody>
-          <a:bodyPr wrap="none">
-            <a:spAutoFit/>
-          </a:bodyPr>
-          <a:lstStyle/>
-          <a:p>
-            <a:pPr algn="ctr">
-              <a:defRPr sz="1400" b="1">
-                <a:solidFill>
-                  <a:srgbClr val="FFFFFF"/>
-                </a:solidFill>
-              </a:defRPr>
-            </a:pPr>
-            <a:r>
-              <a:t>APR</a:t>
-            </a:r>
-          </a:p>
-          <a:p>
-            <a:pPr algn="ctr">
-              <a:defRPr sz="2800" b="1">
-                <a:solidFill>
-                  <a:srgbClr val="FFFFFF"/>
-                </a:solidFill>
-              </a:defRPr>
-            </a:pPr>
-            <a:r>
-              <a:t>09</a:t>
-            </a:r>
-          </a:p>
-        </p:txBody>
-      </p:sp>
-      <p:sp>
-        <p:nvSpPr>
-          <p:cNvPr id="18" name="TextBox 17"/>
-          <p:cNvSpPr txBox="1"/>
-          <p:nvPr/>
-        </p:nvSpPr>
-        <p:spPr>
-          <a:xfrm>
-            <a:off x="2286000" y="5623560"/>
-            <a:ext cx="8991295" cy="822960"/>
-          </a:xfrm>
-          <a:prstGeom prst="rect">
-            <a:avLst/>
-          </a:prstGeom>
-          <a:noFill/>
-        </p:spPr>
-        <p:txBody>
-          <a:bodyPr wrap="square">
-            <a:spAutoFit/>
-          </a:bodyPr>
-          <a:lstStyle/>
-          <a:p>
-            <a:pPr>
-              <a:defRPr sz="1200" b="1">
-                <a:solidFill>
-                  <a:srgbClr val="DA770D"/>
-                </a:solidFill>
-              </a:defRPr>
-            </a:pPr>
-            <a:r>
-              <a:t>Webinar (Free)</a:t>
-            </a:r>
-          </a:p>
-          <a:p>
-            <a:pPr>
-              <a:defRPr sz="2200" b="1">
-                <a:solidFill>
-                  <a:srgbClr val="1C1C1C"/>
-                </a:solidFill>
-              </a:defRPr>
-            </a:pPr>
-            <a:r>
-              <a:t>Cost-Effectiveness: The Basics</a:t>
-            </a:r>
-          </a:p>
-          <a:p>
-            <a:pPr>
-              <a:defRPr sz="1400">
-                <a:solidFill>
-                  <a:srgbClr val="424242"/>
-                </a:solidFill>
-              </a:defRPr>
-            </a:pPr>
-            <a:r>
-              <a:t>12:00 PM - 1:00 PM PT</a:t>
+              <a:t>caphegroup.org</a:t>
             </a:r>
           </a:p>
         </p:txBody>
@@ -4367,7 +3936,7 @@
         <p:spPr>
           <a:xfrm>
             <a:off x="0" y="0"/>
-            <a:ext cx="12191695" cy="6858000"/>
+            <a:ext cx="12191695" cy="1371600"/>
           </a:xfrm>
           <a:prstGeom prst="rect">
             <a:avLst/>
@@ -4409,8 +3978,8 @@
         </p:nvSpPr>
         <p:spPr>
           <a:xfrm>
-            <a:off x="457200" y="2286000"/>
-            <a:ext cx="11277295" cy="914400"/>
+            <a:off x="685800" y="320040"/>
+            <a:ext cx="10820095" cy="457200"/>
           </a:xfrm>
           <a:prstGeom prst="rect">
             <a:avLst/>
@@ -4423,15 +3992,15 @@
           </a:bodyPr>
           <a:lstStyle/>
           <a:p>
-            <a:pPr algn="ctr">
-              <a:defRPr sz="6000" b="1">
-                <a:solidFill>
-                  <a:srgbClr val="FFFFFF"/>
-                </a:solidFill>
-              </a:defRPr>
-            </a:pPr>
-            <a:r>
-              <a:t>Thank You!</a:t>
+            <a:pPr>
+              <a:defRPr sz="1400" b="1">
+                <a:solidFill>
+                  <a:srgbClr val="DA770D"/>
+                </a:solidFill>
+              </a:defRPr>
+            </a:pPr>
+            <a:r>
+              <a:t>DEMO</a:t>
             </a:r>
           </a:p>
         </p:txBody>
@@ -4444,8 +4013,8 @@
         </p:nvSpPr>
         <p:spPr>
           <a:xfrm>
-            <a:off x="457200" y="3657600"/>
-            <a:ext cx="11277295" cy="685800"/>
+            <a:off x="685800" y="685800"/>
+            <a:ext cx="10820095" cy="685800"/>
           </a:xfrm>
           <a:prstGeom prst="rect">
             <a:avLst/>
@@ -4458,15 +4027,15 @@
           </a:bodyPr>
           <a:lstStyle/>
           <a:p>
-            <a:pPr algn="ctr">
-              <a:defRPr sz="3200" b="1">
-                <a:solidFill>
-                  <a:srgbClr val="DA770D"/>
-                </a:solidFill>
-              </a:defRPr>
-            </a:pPr>
-            <a:r>
-              <a:t>caphegroup.org</a:t>
+            <a:pPr>
+              <a:defRPr sz="3400" b="1">
+                <a:solidFill>
+                  <a:srgbClr val="FFFFFF"/>
+                </a:solidFill>
+              </a:defRPr>
+            </a:pPr>
+            <a:r>
+              <a:t>Methods Lab: 35 Interactive Learning Modules</a:t>
             </a:r>
           </a:p>
         </p:txBody>
@@ -4479,7 +4048,2102 @@
         </p:nvSpPr>
         <p:spPr>
           <a:xfrm>
-            <a:off x="457200" y="4572000"/>
+            <a:off x="685800" y="1737360"/>
+            <a:ext cx="5486400" cy="4572000"/>
+          </a:xfrm>
+          <a:prstGeom prst="rect">
+            <a:avLst/>
+          </a:prstGeom>
+          <a:noFill/>
+        </p:spPr>
+        <p:txBody>
+          <a:bodyPr wrap="square">
+            <a:spAutoFit/>
+          </a:bodyPr>
+          <a:lstStyle/>
+          <a:p>
+            <a:pPr>
+              <a:defRPr sz="2200" b="1">
+                <a:solidFill>
+                  <a:srgbClr val="003080"/>
+                </a:solidFill>
+              </a:defRPr>
+            </a:pPr>
+            <a:r>
+              <a:t>Topics Covered</a:t>
+            </a:r>
+          </a:p>
+          <a:p>
+            <a:pPr>
+              <a:spcBef>
+                <a:spcPts val="800"/>
+              </a:spcBef>
+              <a:defRPr sz="1800">
+                <a:solidFill>
+                  <a:srgbClr val="1C1C1C"/>
+                </a:solidFill>
+              </a:defRPr>
+            </a:pPr>
+            <a:r>
+              <a:t>• Causal inference fundamentals</a:t>
+            </a:r>
+          </a:p>
+          <a:p>
+            <a:pPr>
+              <a:spcBef>
+                <a:spcPts val="800"/>
+              </a:spcBef>
+              <a:defRPr sz="1800">
+                <a:solidFill>
+                  <a:srgbClr val="1C1C1C"/>
+                </a:solidFill>
+              </a:defRPr>
+            </a:pPr>
+            <a:r>
+              <a:t>• Threats to validity</a:t>
+            </a:r>
+          </a:p>
+          <a:p>
+            <a:pPr>
+              <a:spcBef>
+                <a:spcPts val="800"/>
+              </a:spcBef>
+              <a:defRPr sz="1800">
+                <a:solidFill>
+                  <a:srgbClr val="1C1C1C"/>
+                </a:solidFill>
+              </a:defRPr>
+            </a:pPr>
+            <a:r>
+              <a:t>• Cost-effectiveness analysis</a:t>
+            </a:r>
+          </a:p>
+          <a:p>
+            <a:pPr>
+              <a:spcBef>
+                <a:spcPts val="800"/>
+              </a:spcBef>
+              <a:defRPr sz="1800">
+                <a:solidFill>
+                  <a:srgbClr val="1C1C1C"/>
+                </a:solidFill>
+              </a:defRPr>
+            </a:pPr>
+            <a:r>
+              <a:t>• California case studies</a:t>
+            </a:r>
+          </a:p>
+          <a:p>
+            <a:pPr>
+              <a:spcBef>
+                <a:spcPts val="800"/>
+              </a:spcBef>
+              <a:defRPr sz="1800">
+                <a:solidFill>
+                  <a:srgbClr val="1C1C1C"/>
+                </a:solidFill>
+              </a:defRPr>
+            </a:pPr>
+            <a:r>
+              <a:t>• Interactive simulations</a:t>
+            </a:r>
+          </a:p>
+        </p:txBody>
+      </p:sp>
+      <p:sp>
+        <p:nvSpPr>
+          <p:cNvPr id="6" name="Rectangle 5"/>
+          <p:cNvSpPr/>
+          <p:nvPr/>
+        </p:nvSpPr>
+        <p:spPr>
+          <a:xfrm>
+            <a:off x="6400800" y="2011680"/>
+            <a:ext cx="5029200" cy="2286000"/>
+          </a:xfrm>
+          <a:prstGeom prst="rect">
+            <a:avLst/>
+          </a:prstGeom>
+          <a:solidFill>
+            <a:srgbClr val="FFF8EB"/>
+          </a:solidFill>
+          <a:ln>
+            <a:solidFill>
+              <a:srgbClr val="DA770D"/>
+            </a:solidFill>
+          </a:ln>
+        </p:spPr>
+        <p:style>
+          <a:lnRef idx="1">
+            <a:schemeClr val="accent1"/>
+          </a:lnRef>
+          <a:fillRef idx="3">
+            <a:schemeClr val="accent1"/>
+          </a:fillRef>
+          <a:effectRef idx="2">
+            <a:schemeClr val="accent1"/>
+          </a:effectRef>
+          <a:fontRef idx="minor">
+            <a:schemeClr val="lt1"/>
+          </a:fontRef>
+        </p:style>
+        <p:txBody>
+          <a:bodyPr rtlCol="0" anchor="ctr"/>
+          <a:lstStyle/>
+          <a:p>
+            <a:pPr algn="ctr"/>
+          </a:p>
+        </p:txBody>
+      </p:sp>
+      <p:sp>
+        <p:nvSpPr>
+          <p:cNvPr id="7" name="TextBox 6"/>
+          <p:cNvSpPr txBox="1"/>
+          <p:nvPr/>
+        </p:nvSpPr>
+        <p:spPr>
+          <a:xfrm>
+            <a:off x="6629400" y="2194560"/>
+            <a:ext cx="4572000" cy="2011680"/>
+          </a:xfrm>
+          <a:prstGeom prst="rect">
+            <a:avLst/>
+          </a:prstGeom>
+          <a:noFill/>
+        </p:spPr>
+        <p:txBody>
+          <a:bodyPr wrap="square">
+            <a:spAutoFit/>
+          </a:bodyPr>
+          <a:lstStyle/>
+          <a:p>
+            <a:pPr>
+              <a:defRPr sz="2000" b="1">
+                <a:solidFill>
+                  <a:srgbClr val="DA770D"/>
+                </a:solidFill>
+              </a:defRPr>
+            </a:pPr>
+            <a:r>
+              <a:t>Discussion</a:t>
+            </a:r>
+          </a:p>
+          <a:p>
+            <a:pPr>
+              <a:spcBef>
+                <a:spcPts val="1200"/>
+              </a:spcBef>
+              <a:defRPr sz="1800">
+                <a:solidFill>
+                  <a:srgbClr val="1C1C1C"/>
+                </a:solidFill>
+              </a:defRPr>
+            </a:pPr>
+            <a:r>
+              <a:t>What topics would be most useful for new labs?</a:t>
+            </a:r>
+          </a:p>
+        </p:txBody>
+      </p:sp>
+      <p:sp>
+        <p:nvSpPr>
+          <p:cNvPr id="8" name="TextBox 7"/>
+          <p:cNvSpPr txBox="1"/>
+          <p:nvPr/>
+        </p:nvSpPr>
+        <p:spPr>
+          <a:xfrm>
+            <a:off x="6400800" y="5029200"/>
+            <a:ext cx="5029200" cy="914400"/>
+          </a:xfrm>
+          <a:prstGeom prst="rect">
+            <a:avLst/>
+          </a:prstGeom>
+          <a:noFill/>
+        </p:spPr>
+        <p:txBody>
+          <a:bodyPr wrap="none">
+            <a:spAutoFit/>
+          </a:bodyPr>
+          <a:lstStyle/>
+          <a:p>
+            <a:pPr algn="ctr">
+              <a:defRPr sz="2200" b="1">
+                <a:solidFill>
+                  <a:srgbClr val="DA770D"/>
+                </a:solidFill>
+              </a:defRPr>
+            </a:pPr>
+            <a:r>
+              <a:t>caphegroup.org/methods-lab</a:t>
+            </a:r>
+          </a:p>
+        </p:txBody>
+      </p:sp>
+    </p:spTree>
+  </p:cSld>
+  <p:clrMapOvr>
+    <a:masterClrMapping/>
+  </p:clrMapOvr>
+</p:sld>
+</file>
+
+<file path=ppt/slides/slide5.xml><?xml version="1.0" encoding="utf-8"?>
+<p:sld xmlns:a="http://schemas.openxmlformats.org/drawingml/2006/main" xmlns:p="http://schemas.openxmlformats.org/presentationml/2006/main" xmlns:r="http://schemas.openxmlformats.org/officeDocument/2006/relationships">
+  <p:cSld>
+    <p:spTree>
+      <p:nvGrpSpPr>
+        <p:cNvPr id="1" name=""/>
+        <p:cNvGrpSpPr/>
+        <p:nvPr/>
+      </p:nvGrpSpPr>
+      <p:grpSpPr/>
+      <p:sp>
+        <p:nvSpPr>
+          <p:cNvPr id="2" name="Rectangle 1"/>
+          <p:cNvSpPr/>
+          <p:nvPr/>
+        </p:nvSpPr>
+        <p:spPr>
+          <a:xfrm>
+            <a:off x="0" y="0"/>
+            <a:ext cx="12191695" cy="137160"/>
+          </a:xfrm>
+          <a:prstGeom prst="rect">
+            <a:avLst/>
+          </a:prstGeom>
+          <a:solidFill>
+            <a:srgbClr val="003080"/>
+          </a:solidFill>
+          <a:ln>
+            <a:noFill/>
+          </a:ln>
+        </p:spPr>
+        <p:style>
+          <a:lnRef idx="1">
+            <a:schemeClr val="accent1"/>
+          </a:lnRef>
+          <a:fillRef idx="3">
+            <a:schemeClr val="accent1"/>
+          </a:fillRef>
+          <a:effectRef idx="2">
+            <a:schemeClr val="accent1"/>
+          </a:effectRef>
+          <a:fontRef idx="minor">
+            <a:schemeClr val="lt1"/>
+          </a:fontRef>
+        </p:style>
+        <p:txBody>
+          <a:bodyPr rtlCol="0" anchor="ctr"/>
+          <a:lstStyle/>
+          <a:p>
+            <a:pPr algn="ctr"/>
+          </a:p>
+        </p:txBody>
+      </p:sp>
+      <p:sp>
+        <p:nvSpPr>
+          <p:cNvPr id="3" name="TextBox 2"/>
+          <p:cNvSpPr txBox="1"/>
+          <p:nvPr/>
+        </p:nvSpPr>
+        <p:spPr>
+          <a:xfrm>
+            <a:off x="685800" y="457200"/>
+            <a:ext cx="10820095" cy="914400"/>
+          </a:xfrm>
+          <a:prstGeom prst="rect">
+            <a:avLst/>
+          </a:prstGeom>
+          <a:noFill/>
+        </p:spPr>
+        <p:txBody>
+          <a:bodyPr wrap="none">
+            <a:spAutoFit/>
+          </a:bodyPr>
+          <a:lstStyle/>
+          <a:p>
+            <a:pPr>
+              <a:defRPr sz="4000" b="1">
+                <a:solidFill>
+                  <a:srgbClr val="003080"/>
+                </a:solidFill>
+              </a:defRPr>
+            </a:pPr>
+            <a:r>
+              <a:t>Announcements</a:t>
+            </a:r>
+          </a:p>
+        </p:txBody>
+      </p:sp>
+      <p:sp>
+        <p:nvSpPr>
+          <p:cNvPr id="4" name="Rectangle 3"/>
+          <p:cNvSpPr/>
+          <p:nvPr/>
+        </p:nvSpPr>
+        <p:spPr>
+          <a:xfrm>
+            <a:off x="685800" y="1463040"/>
+            <a:ext cx="5029200" cy="2011680"/>
+          </a:xfrm>
+          <a:prstGeom prst="rect">
+            <a:avLst/>
+          </a:prstGeom>
+          <a:solidFill>
+            <a:srgbClr val="F0F5FF"/>
+          </a:solidFill>
+          <a:ln>
+            <a:solidFill>
+              <a:srgbClr val="003080"/>
+            </a:solidFill>
+          </a:ln>
+        </p:spPr>
+        <p:style>
+          <a:lnRef idx="1">
+            <a:schemeClr val="accent1"/>
+          </a:lnRef>
+          <a:fillRef idx="3">
+            <a:schemeClr val="accent1"/>
+          </a:fillRef>
+          <a:effectRef idx="2">
+            <a:schemeClr val="accent1"/>
+          </a:effectRef>
+          <a:fontRef idx="minor">
+            <a:schemeClr val="lt1"/>
+          </a:fontRef>
+        </p:style>
+        <p:txBody>
+          <a:bodyPr rtlCol="0" anchor="ctr"/>
+          <a:lstStyle/>
+          <a:p>
+            <a:pPr algn="ctr"/>
+          </a:p>
+        </p:txBody>
+      </p:sp>
+      <p:sp>
+        <p:nvSpPr>
+          <p:cNvPr id="5" name="TextBox 4"/>
+          <p:cNvSpPr txBox="1"/>
+          <p:nvPr/>
+        </p:nvSpPr>
+        <p:spPr>
+          <a:xfrm>
+            <a:off x="914400" y="1645920"/>
+            <a:ext cx="4572000" cy="1828800"/>
+          </a:xfrm>
+          <a:prstGeom prst="rect">
+            <a:avLst/>
+          </a:prstGeom>
+          <a:noFill/>
+        </p:spPr>
+        <p:txBody>
+          <a:bodyPr wrap="square">
+            <a:spAutoFit/>
+          </a:bodyPr>
+          <a:lstStyle/>
+          <a:p>
+            <a:pPr>
+              <a:defRPr sz="1400" b="1">
+                <a:solidFill>
+                  <a:srgbClr val="DA770D"/>
+                </a:solidFill>
+              </a:defRPr>
+            </a:pPr>
+            <a:r>
+              <a:t>WEBINAR • FEBRUARY 12</a:t>
+            </a:r>
+          </a:p>
+          <a:p>
+            <a:pPr>
+              <a:spcBef>
+                <a:spcPts val="800"/>
+              </a:spcBef>
+              <a:defRPr sz="2200" b="1">
+                <a:solidFill>
+                  <a:srgbClr val="003080"/>
+                </a:solidFill>
+              </a:defRPr>
+            </a:pPr>
+            <a:r>
+              <a:t>Introduction to Health Economics</a:t>
+            </a:r>
+          </a:p>
+          <a:p>
+            <a:pPr>
+              <a:spcBef>
+                <a:spcPts val="800"/>
+              </a:spcBef>
+              <a:defRPr sz="1600">
+                <a:solidFill>
+                  <a:srgbClr val="424242"/>
+                </a:solidFill>
+              </a:defRPr>
+            </a:pPr>
+            <a:r>
+              <a:t>12:00 PM PT • Free &amp; open to all</a:t>
+            </a:r>
+          </a:p>
+        </p:txBody>
+      </p:sp>
+      <p:sp>
+        <p:nvSpPr>
+          <p:cNvPr id="6" name="Rectangle 5"/>
+          <p:cNvSpPr/>
+          <p:nvPr/>
+        </p:nvSpPr>
+        <p:spPr>
+          <a:xfrm>
+            <a:off x="6400800" y="1463040"/>
+            <a:ext cx="5029200" cy="2011680"/>
+          </a:xfrm>
+          <a:prstGeom prst="rect">
+            <a:avLst/>
+          </a:prstGeom>
+          <a:solidFill>
+            <a:srgbClr val="FFF8EB"/>
+          </a:solidFill>
+          <a:ln>
+            <a:solidFill>
+              <a:srgbClr val="DA770D"/>
+            </a:solidFill>
+          </a:ln>
+        </p:spPr>
+        <p:style>
+          <a:lnRef idx="1">
+            <a:schemeClr val="accent1"/>
+          </a:lnRef>
+          <a:fillRef idx="3">
+            <a:schemeClr val="accent1"/>
+          </a:fillRef>
+          <a:effectRef idx="2">
+            <a:schemeClr val="accent1"/>
+          </a:effectRef>
+          <a:fontRef idx="minor">
+            <a:schemeClr val="lt1"/>
+          </a:fontRef>
+        </p:style>
+        <p:txBody>
+          <a:bodyPr rtlCol="0" anchor="ctr"/>
+          <a:lstStyle/>
+          <a:p>
+            <a:pPr algn="ctr"/>
+          </a:p>
+        </p:txBody>
+      </p:sp>
+      <p:sp>
+        <p:nvSpPr>
+          <p:cNvPr id="7" name="TextBox 6"/>
+          <p:cNvSpPr txBox="1"/>
+          <p:nvPr/>
+        </p:nvSpPr>
+        <p:spPr>
+          <a:xfrm>
+            <a:off x="6629400" y="1645920"/>
+            <a:ext cx="4572000" cy="1828800"/>
+          </a:xfrm>
+          <a:prstGeom prst="rect">
+            <a:avLst/>
+          </a:prstGeom>
+          <a:noFill/>
+        </p:spPr>
+        <p:txBody>
+          <a:bodyPr wrap="square">
+            <a:spAutoFit/>
+          </a:bodyPr>
+          <a:lstStyle/>
+          <a:p>
+            <a:pPr>
+              <a:defRPr sz="1400" b="1">
+                <a:solidFill>
+                  <a:srgbClr val="DA770D"/>
+                </a:solidFill>
+              </a:defRPr>
+            </a:pPr>
+            <a:r>
+              <a:t>MARCH 25 MEETING</a:t>
+            </a:r>
+          </a:p>
+          <a:p>
+            <a:pPr>
+              <a:spcBef>
+                <a:spcPts val="800"/>
+              </a:spcBef>
+              <a:defRPr sz="2200" b="1">
+                <a:solidFill>
+                  <a:srgbClr val="003080"/>
+                </a:solidFill>
+              </a:defRPr>
+            </a:pPr>
+            <a:r>
+              <a:t>Tim Brown</a:t>
+            </a:r>
+          </a:p>
+          <a:p>
+            <a:pPr>
+              <a:spcBef>
+                <a:spcPts val="800"/>
+              </a:spcBef>
+              <a:defRPr sz="1600">
+                <a:solidFill>
+                  <a:srgbClr val="1C1C1C"/>
+                </a:solidFill>
+              </a:defRPr>
+            </a:pPr>
+            <a:r>
+              <a:t>ROI of Public Health Spending on Hospital Utilization</a:t>
+            </a:r>
+          </a:p>
+        </p:txBody>
+      </p:sp>
+      <p:sp>
+        <p:nvSpPr>
+          <p:cNvPr id="8" name="TextBox 7"/>
+          <p:cNvSpPr txBox="1"/>
+          <p:nvPr/>
+        </p:nvSpPr>
+        <p:spPr>
+          <a:xfrm>
+            <a:off x="685800" y="4114800"/>
+            <a:ext cx="10820095" cy="1828800"/>
+          </a:xfrm>
+          <a:prstGeom prst="rect">
+            <a:avLst/>
+          </a:prstGeom>
+          <a:noFill/>
+        </p:spPr>
+        <p:txBody>
+          <a:bodyPr wrap="square">
+            <a:spAutoFit/>
+          </a:bodyPr>
+          <a:lstStyle/>
+          <a:p>
+            <a:pPr>
+              <a:defRPr sz="2400" b="1">
+                <a:solidFill>
+                  <a:srgbClr val="003080"/>
+                </a:solidFill>
+              </a:defRPr>
+            </a:pPr>
+            <a:r>
+              <a:t>Discussion: Fall 2026 Webinar Topics</a:t>
+            </a:r>
+          </a:p>
+          <a:p>
+            <a:pPr>
+              <a:spcBef>
+                <a:spcPts val="1200"/>
+              </a:spcBef>
+              <a:defRPr sz="1800">
+                <a:solidFill>
+                  <a:srgbClr val="424242"/>
+                </a:solidFill>
+              </a:defRPr>
+            </a:pPr>
+            <a:r>
+              <a:t>What topics should we cover? Suggestions welcome!</a:t>
+            </a:r>
+          </a:p>
+        </p:txBody>
+      </p:sp>
+    </p:spTree>
+  </p:cSld>
+  <p:clrMapOvr>
+    <a:masterClrMapping/>
+  </p:clrMapOvr>
+</p:sld>
+</file>
+
+<file path=ppt/slides/slide6.xml><?xml version="1.0" encoding="utf-8"?>
+<p:sld xmlns:a="http://schemas.openxmlformats.org/drawingml/2006/main" xmlns:p="http://schemas.openxmlformats.org/presentationml/2006/main" xmlns:r="http://schemas.openxmlformats.org/officeDocument/2006/relationships">
+  <p:cSld>
+    <p:spTree>
+      <p:nvGrpSpPr>
+        <p:cNvPr id="1" name=""/>
+        <p:cNvGrpSpPr/>
+        <p:nvPr/>
+      </p:nvGrpSpPr>
+      <p:grpSpPr/>
+      <p:sp>
+        <p:nvSpPr>
+          <p:cNvPr id="2" name="Rectangle 1"/>
+          <p:cNvSpPr/>
+          <p:nvPr/>
+        </p:nvSpPr>
+        <p:spPr>
+          <a:xfrm>
+            <a:off x="0" y="0"/>
+            <a:ext cx="12191695" cy="137160"/>
+          </a:xfrm>
+          <a:prstGeom prst="rect">
+            <a:avLst/>
+          </a:prstGeom>
+          <a:solidFill>
+            <a:srgbClr val="003080"/>
+          </a:solidFill>
+          <a:ln>
+            <a:noFill/>
+          </a:ln>
+        </p:spPr>
+        <p:style>
+          <a:lnRef idx="1">
+            <a:schemeClr val="accent1"/>
+          </a:lnRef>
+          <a:fillRef idx="3">
+            <a:schemeClr val="accent1"/>
+          </a:fillRef>
+          <a:effectRef idx="2">
+            <a:schemeClr val="accent1"/>
+          </a:effectRef>
+          <a:fontRef idx="minor">
+            <a:schemeClr val="lt1"/>
+          </a:fontRef>
+        </p:style>
+        <p:txBody>
+          <a:bodyPr rtlCol="0" anchor="ctr"/>
+          <a:lstStyle/>
+          <a:p>
+            <a:pPr algn="ctr"/>
+          </a:p>
+        </p:txBody>
+      </p:sp>
+      <p:sp>
+        <p:nvSpPr>
+          <p:cNvPr id="3" name="TextBox 2"/>
+          <p:cNvSpPr txBox="1"/>
+          <p:nvPr/>
+        </p:nvSpPr>
+        <p:spPr>
+          <a:xfrm>
+            <a:off x="685800" y="457200"/>
+            <a:ext cx="10820095" cy="914400"/>
+          </a:xfrm>
+          <a:prstGeom prst="rect">
+            <a:avLst/>
+          </a:prstGeom>
+          <a:noFill/>
+        </p:spPr>
+        <p:txBody>
+          <a:bodyPr wrap="none">
+            <a:spAutoFit/>
+          </a:bodyPr>
+          <a:lstStyle/>
+          <a:p>
+            <a:pPr>
+              <a:defRPr sz="4000" b="1">
+                <a:solidFill>
+                  <a:srgbClr val="003080"/>
+                </a:solidFill>
+              </a:defRPr>
+            </a:pPr>
+            <a:r>
+              <a:t>Governance Documents for Review</a:t>
+            </a:r>
+          </a:p>
+        </p:txBody>
+      </p:sp>
+      <p:sp>
+        <p:nvSpPr>
+          <p:cNvPr id="4" name="TextBox 3"/>
+          <p:cNvSpPr txBox="1"/>
+          <p:nvPr/>
+        </p:nvSpPr>
+        <p:spPr>
+          <a:xfrm>
+            <a:off x="685800" y="1554480"/>
+            <a:ext cx="5486400" cy="3657600"/>
+          </a:xfrm>
+          <a:prstGeom prst="rect">
+            <a:avLst/>
+          </a:prstGeom>
+          <a:noFill/>
+        </p:spPr>
+        <p:txBody>
+          <a:bodyPr wrap="square">
+            <a:spAutoFit/>
+          </a:bodyPr>
+          <a:lstStyle/>
+          <a:p>
+            <a:pPr>
+              <a:spcAft>
+                <a:spcPts val="1200"/>
+              </a:spcAft>
+              <a:defRPr sz="2200">
+                <a:solidFill>
+                  <a:srgbClr val="1C1C1C"/>
+                </a:solidFill>
+              </a:defRPr>
+            </a:pPr>
+            <a:r>
+              <a:t>• Articles of Organization</a:t>
+            </a:r>
+          </a:p>
+          <a:p>
+            <a:pPr>
+              <a:spcAft>
+                <a:spcPts val="1200"/>
+              </a:spcAft>
+              <a:defRPr sz="2200">
+                <a:solidFill>
+                  <a:srgbClr val="1C1C1C"/>
+                </a:solidFill>
+              </a:defRPr>
+            </a:pPr>
+            <a:r>
+              <a:t>• Bylaws</a:t>
+            </a:r>
+          </a:p>
+          <a:p>
+            <a:pPr>
+              <a:spcAft>
+                <a:spcPts val="1200"/>
+              </a:spcAft>
+              <a:defRPr sz="2200">
+                <a:solidFill>
+                  <a:srgbClr val="1C1C1C"/>
+                </a:solidFill>
+              </a:defRPr>
+            </a:pPr>
+            <a:r>
+              <a:t>• Conflict of Interest Policy</a:t>
+            </a:r>
+          </a:p>
+          <a:p>
+            <a:pPr>
+              <a:spcAft>
+                <a:spcPts val="1200"/>
+              </a:spcAft>
+              <a:defRPr sz="2200">
+                <a:solidFill>
+                  <a:srgbClr val="1C1C1C"/>
+                </a:solidFill>
+              </a:defRPr>
+            </a:pPr>
+            <a:r>
+              <a:t>• Initial Board Meeting Minutes Template</a:t>
+            </a:r>
+          </a:p>
+          <a:p>
+            <a:pPr>
+              <a:spcAft>
+                <a:spcPts val="1200"/>
+              </a:spcAft>
+              <a:defRPr sz="2200">
+                <a:solidFill>
+                  <a:srgbClr val="1C1C1C"/>
+                </a:solidFill>
+              </a:defRPr>
+            </a:pPr>
+            <a:r>
+              <a:t>• 501(c)(3) Filing Checklist</a:t>
+            </a:r>
+          </a:p>
+        </p:txBody>
+      </p:sp>
+      <p:sp>
+        <p:nvSpPr>
+          <p:cNvPr id="5" name="Rectangle 4"/>
+          <p:cNvSpPr/>
+          <p:nvPr/>
+        </p:nvSpPr>
+        <p:spPr>
+          <a:xfrm>
+            <a:off x="6400800" y="1554480"/>
+            <a:ext cx="5029200" cy="2286000"/>
+          </a:xfrm>
+          <a:prstGeom prst="rect">
+            <a:avLst/>
+          </a:prstGeom>
+          <a:solidFill>
+            <a:srgbClr val="FFF8EB"/>
+          </a:solidFill>
+          <a:ln>
+            <a:solidFill>
+              <a:srgbClr val="DA770D"/>
+            </a:solidFill>
+          </a:ln>
+        </p:spPr>
+        <p:style>
+          <a:lnRef idx="1">
+            <a:schemeClr val="accent1"/>
+          </a:lnRef>
+          <a:fillRef idx="3">
+            <a:schemeClr val="accent1"/>
+          </a:fillRef>
+          <a:effectRef idx="2">
+            <a:schemeClr val="accent1"/>
+          </a:effectRef>
+          <a:fontRef idx="minor">
+            <a:schemeClr val="lt1"/>
+          </a:fontRef>
+        </p:style>
+        <p:txBody>
+          <a:bodyPr rtlCol="0" anchor="ctr"/>
+          <a:lstStyle/>
+          <a:p>
+            <a:pPr algn="ctr"/>
+          </a:p>
+        </p:txBody>
+      </p:sp>
+      <p:sp>
+        <p:nvSpPr>
+          <p:cNvPr id="6" name="TextBox 5"/>
+          <p:cNvSpPr txBox="1"/>
+          <p:nvPr/>
+        </p:nvSpPr>
+        <p:spPr>
+          <a:xfrm>
+            <a:off x="6629400" y="1737360"/>
+            <a:ext cx="4572000" cy="2011680"/>
+          </a:xfrm>
+          <a:prstGeom prst="rect">
+            <a:avLst/>
+          </a:prstGeom>
+          <a:noFill/>
+        </p:spPr>
+        <p:txBody>
+          <a:bodyPr wrap="square">
+            <a:spAutoFit/>
+          </a:bodyPr>
+          <a:lstStyle/>
+          <a:p>
+            <a:pPr>
+              <a:defRPr sz="1400" b="1">
+                <a:solidFill>
+                  <a:srgbClr val="DA770D"/>
+                </a:solidFill>
+              </a:defRPr>
+            </a:pPr>
+            <a:r>
+              <a:t>ACTION REQUESTED</a:t>
+            </a:r>
+          </a:p>
+          <a:p>
+            <a:pPr>
+              <a:spcBef>
+                <a:spcPts val="1200"/>
+              </a:spcBef>
+              <a:defRPr sz="1800">
+                <a:solidFill>
+                  <a:srgbClr val="1C1C1C"/>
+                </a:solidFill>
+              </a:defRPr>
+            </a:pPr>
+            <a:r>
+              <a:t>Review documents and provide feedback</a:t>
+            </a:r>
+          </a:p>
+          <a:p>
+            <a:pPr>
+              <a:spcBef>
+                <a:spcPts val="1200"/>
+              </a:spcBef>
+              <a:defRPr sz="1800" b="1">
+                <a:solidFill>
+                  <a:srgbClr val="003080"/>
+                </a:solidFill>
+              </a:defRPr>
+            </a:pPr>
+            <a:r>
+              <a:t>Due: February 25, 2026</a:t>
+            </a:r>
+          </a:p>
+        </p:txBody>
+      </p:sp>
+      <p:sp>
+        <p:nvSpPr>
+          <p:cNvPr id="7" name="TextBox 6"/>
+          <p:cNvSpPr txBox="1"/>
+          <p:nvPr/>
+        </p:nvSpPr>
+        <p:spPr>
+          <a:xfrm>
+            <a:off x="685800" y="5029200"/>
+            <a:ext cx="10820095" cy="914400"/>
+          </a:xfrm>
+          <a:prstGeom prst="rect">
+            <a:avLst/>
+          </a:prstGeom>
+          <a:noFill/>
+        </p:spPr>
+        <p:txBody>
+          <a:bodyPr wrap="none">
+            <a:spAutoFit/>
+          </a:bodyPr>
+          <a:lstStyle/>
+          <a:p>
+            <a:pPr>
+              <a:defRPr sz="1800">
+                <a:solidFill>
+                  <a:srgbClr val="424242"/>
+                </a:solidFill>
+              </a:defRPr>
+            </a:pPr>
+            <a:r>
+              <a:t>Location: Google Drive → CAPHE folder (link will be shared via email)</a:t>
+            </a:r>
+          </a:p>
+        </p:txBody>
+      </p:sp>
+    </p:spTree>
+  </p:cSld>
+  <p:clrMapOvr>
+    <a:masterClrMapping/>
+  </p:clrMapOvr>
+</p:sld>
+</file>
+
+<file path=ppt/slides/slide7.xml><?xml version="1.0" encoding="utf-8"?>
+<p:sld xmlns:a="http://schemas.openxmlformats.org/drawingml/2006/main" xmlns:p="http://schemas.openxmlformats.org/presentationml/2006/main" xmlns:r="http://schemas.openxmlformats.org/officeDocument/2006/relationships">
+  <p:cSld>
+    <p:spTree>
+      <p:nvGrpSpPr>
+        <p:cNvPr id="1" name=""/>
+        <p:cNvGrpSpPr/>
+        <p:nvPr/>
+      </p:nvGrpSpPr>
+      <p:grpSpPr/>
+      <p:sp>
+        <p:nvSpPr>
+          <p:cNvPr id="2" name="Rectangle 1"/>
+          <p:cNvSpPr/>
+          <p:nvPr/>
+        </p:nvSpPr>
+        <p:spPr>
+          <a:xfrm>
+            <a:off x="0" y="0"/>
+            <a:ext cx="12191695" cy="137160"/>
+          </a:xfrm>
+          <a:prstGeom prst="rect">
+            <a:avLst/>
+          </a:prstGeom>
+          <a:solidFill>
+            <a:srgbClr val="003080"/>
+          </a:solidFill>
+          <a:ln>
+            <a:noFill/>
+          </a:ln>
+        </p:spPr>
+        <p:style>
+          <a:lnRef idx="1">
+            <a:schemeClr val="accent1"/>
+          </a:lnRef>
+          <a:fillRef idx="3">
+            <a:schemeClr val="accent1"/>
+          </a:fillRef>
+          <a:effectRef idx="2">
+            <a:schemeClr val="accent1"/>
+          </a:effectRef>
+          <a:fontRef idx="minor">
+            <a:schemeClr val="lt1"/>
+          </a:fontRef>
+        </p:style>
+        <p:txBody>
+          <a:bodyPr rtlCol="0" anchor="ctr"/>
+          <a:lstStyle/>
+          <a:p>
+            <a:pPr algn="ctr"/>
+          </a:p>
+        </p:txBody>
+      </p:sp>
+      <p:sp>
+        <p:nvSpPr>
+          <p:cNvPr id="3" name="TextBox 2"/>
+          <p:cNvSpPr txBox="1"/>
+          <p:nvPr/>
+        </p:nvSpPr>
+        <p:spPr>
+          <a:xfrm>
+            <a:off x="685800" y="457200"/>
+            <a:ext cx="10820095" cy="914400"/>
+          </a:xfrm>
+          <a:prstGeom prst="rect">
+            <a:avLst/>
+          </a:prstGeom>
+          <a:noFill/>
+        </p:spPr>
+        <p:txBody>
+          <a:bodyPr wrap="none">
+            <a:spAutoFit/>
+          </a:bodyPr>
+          <a:lstStyle/>
+          <a:p>
+            <a:pPr>
+              <a:defRPr sz="4000" b="1">
+                <a:solidFill>
+                  <a:srgbClr val="003080"/>
+                </a:solidFill>
+              </a:defRPr>
+            </a:pPr>
+            <a:r>
+              <a:t>Letter to Dr. Erika Pan</a:t>
+            </a:r>
+          </a:p>
+        </p:txBody>
+      </p:sp>
+      <p:sp>
+        <p:nvSpPr>
+          <p:cNvPr id="4" name="TextBox 3"/>
+          <p:cNvSpPr txBox="1"/>
+          <p:nvPr/>
+        </p:nvSpPr>
+        <p:spPr>
+          <a:xfrm>
+            <a:off x="685800" y="1554480"/>
+            <a:ext cx="5486400" cy="3657600"/>
+          </a:xfrm>
+          <a:prstGeom prst="rect">
+            <a:avLst/>
+          </a:prstGeom>
+          <a:noFill/>
+        </p:spPr>
+        <p:txBody>
+          <a:bodyPr wrap="square">
+            <a:spAutoFit/>
+          </a:bodyPr>
+          <a:lstStyle/>
+          <a:p>
+            <a:pPr>
+              <a:defRPr sz="2200">
+                <a:solidFill>
+                  <a:srgbClr val="424242"/>
+                </a:solidFill>
+              </a:defRPr>
+            </a:pPr>
+            <a:r>
+              <a:t>California State Epidemiologist</a:t>
+            </a:r>
+          </a:p>
+          <a:p>
+            <a:pPr>
+              <a:spcBef>
+                <a:spcPts val="2000"/>
+              </a:spcBef>
+            </a:pPr>
+          </a:p>
+          <a:p>
+            <a:pPr>
+              <a:defRPr sz="2200" b="1">
+                <a:solidFill>
+                  <a:srgbClr val="003080"/>
+                </a:solidFill>
+              </a:defRPr>
+            </a:pPr>
+            <a:r>
+              <a:t>Purpose:</a:t>
+            </a:r>
+          </a:p>
+          <a:p>
+            <a:pPr>
+              <a:spcBef>
+                <a:spcPts val="800"/>
+              </a:spcBef>
+              <a:defRPr sz="2000">
+                <a:solidFill>
+                  <a:srgbClr val="1C1C1C"/>
+                </a:solidFill>
+              </a:defRPr>
+            </a:pPr>
+            <a:r>
+              <a:t>• Introduce CAPHE and our mission</a:t>
+            </a:r>
+          </a:p>
+          <a:p>
+            <a:pPr>
+              <a:spcBef>
+                <a:spcPts val="800"/>
+              </a:spcBef>
+              <a:defRPr sz="2000">
+                <a:solidFill>
+                  <a:srgbClr val="1C1C1C"/>
+                </a:solidFill>
+              </a:defRPr>
+            </a:pPr>
+            <a:r>
+              <a:t>• Highlight value for CDPH staff</a:t>
+            </a:r>
+          </a:p>
+          <a:p>
+            <a:pPr>
+              <a:spcBef>
+                <a:spcPts val="800"/>
+              </a:spcBef>
+              <a:defRPr sz="2000">
+                <a:solidFill>
+                  <a:srgbClr val="1C1C1C"/>
+                </a:solidFill>
+              </a:defRPr>
+            </a:pPr>
+            <a:r>
+              <a:t>• Explore collaboration opportunities</a:t>
+            </a:r>
+          </a:p>
+        </p:txBody>
+      </p:sp>
+      <p:sp>
+        <p:nvSpPr>
+          <p:cNvPr id="5" name="Rectangle 4"/>
+          <p:cNvSpPr/>
+          <p:nvPr/>
+        </p:nvSpPr>
+        <p:spPr>
+          <a:xfrm>
+            <a:off x="6400800" y="1554480"/>
+            <a:ext cx="5029200" cy="2286000"/>
+          </a:xfrm>
+          <a:prstGeom prst="rect">
+            <a:avLst/>
+          </a:prstGeom>
+          <a:solidFill>
+            <a:srgbClr val="FFF8EB"/>
+          </a:solidFill>
+          <a:ln>
+            <a:solidFill>
+              <a:srgbClr val="DA770D"/>
+            </a:solidFill>
+          </a:ln>
+        </p:spPr>
+        <p:style>
+          <a:lnRef idx="1">
+            <a:schemeClr val="accent1"/>
+          </a:lnRef>
+          <a:fillRef idx="3">
+            <a:schemeClr val="accent1"/>
+          </a:fillRef>
+          <a:effectRef idx="2">
+            <a:schemeClr val="accent1"/>
+          </a:effectRef>
+          <a:fontRef idx="minor">
+            <a:schemeClr val="lt1"/>
+          </a:fontRef>
+        </p:style>
+        <p:txBody>
+          <a:bodyPr rtlCol="0" anchor="ctr"/>
+          <a:lstStyle/>
+          <a:p>
+            <a:pPr algn="ctr"/>
+          </a:p>
+        </p:txBody>
+      </p:sp>
+      <p:sp>
+        <p:nvSpPr>
+          <p:cNvPr id="6" name="TextBox 5"/>
+          <p:cNvSpPr txBox="1"/>
+          <p:nvPr/>
+        </p:nvSpPr>
+        <p:spPr>
+          <a:xfrm>
+            <a:off x="6629400" y="1737360"/>
+            <a:ext cx="4572000" cy="2011680"/>
+          </a:xfrm>
+          <a:prstGeom prst="rect">
+            <a:avLst/>
+          </a:prstGeom>
+          <a:noFill/>
+        </p:spPr>
+        <p:txBody>
+          <a:bodyPr wrap="square">
+            <a:spAutoFit/>
+          </a:bodyPr>
+          <a:lstStyle/>
+          <a:p>
+            <a:pPr>
+              <a:defRPr sz="1400" b="1">
+                <a:solidFill>
+                  <a:srgbClr val="DA770D"/>
+                </a:solidFill>
+              </a:defRPr>
+            </a:pPr>
+            <a:r>
+              <a:t>ACTION REQUESTED</a:t>
+            </a:r>
+          </a:p>
+          <a:p>
+            <a:pPr>
+              <a:spcBef>
+                <a:spcPts val="1200"/>
+              </a:spcBef>
+              <a:defRPr sz="1800">
+                <a:solidFill>
+                  <a:srgbClr val="1C1C1C"/>
+                </a:solidFill>
+              </a:defRPr>
+            </a:pPr>
+            <a:r>
+              <a:t>Review draft and provide comments</a:t>
+            </a:r>
+          </a:p>
+          <a:p>
+            <a:pPr>
+              <a:spcBef>
+                <a:spcPts val="1200"/>
+              </a:spcBef>
+              <a:defRPr sz="1800" b="1">
+                <a:solidFill>
+                  <a:srgbClr val="003080"/>
+                </a:solidFill>
+              </a:defRPr>
+            </a:pPr>
+            <a:r>
+              <a:t>Due: February 14, 2026</a:t>
+            </a:r>
+          </a:p>
+        </p:txBody>
+      </p:sp>
+      <p:sp>
+        <p:nvSpPr>
+          <p:cNvPr id="7" name="TextBox 6"/>
+          <p:cNvSpPr txBox="1"/>
+          <p:nvPr/>
+        </p:nvSpPr>
+        <p:spPr>
+          <a:xfrm>
+            <a:off x="685800" y="5029200"/>
+            <a:ext cx="10820095" cy="914400"/>
+          </a:xfrm>
+          <a:prstGeom prst="rect">
+            <a:avLst/>
+          </a:prstGeom>
+          <a:noFill/>
+        </p:spPr>
+        <p:txBody>
+          <a:bodyPr wrap="none">
+            <a:spAutoFit/>
+          </a:bodyPr>
+          <a:lstStyle/>
+          <a:p>
+            <a:pPr>
+              <a:defRPr sz="1800">
+                <a:solidFill>
+                  <a:srgbClr val="424242"/>
+                </a:solidFill>
+              </a:defRPr>
+            </a:pPr>
+            <a:r>
+              <a:t>Location: Google Drive → CAPHE → CAPHE_Letter.gdoc</a:t>
+            </a:r>
+          </a:p>
+        </p:txBody>
+      </p:sp>
+    </p:spTree>
+  </p:cSld>
+  <p:clrMapOvr>
+    <a:masterClrMapping/>
+  </p:clrMapOvr>
+</p:sld>
+</file>
+
+<file path=ppt/slides/slide8.xml><?xml version="1.0" encoding="utf-8"?>
+<p:sld xmlns:a="http://schemas.openxmlformats.org/drawingml/2006/main" xmlns:p="http://schemas.openxmlformats.org/presentationml/2006/main" xmlns:r="http://schemas.openxmlformats.org/officeDocument/2006/relationships">
+  <p:cSld>
+    <p:spTree>
+      <p:nvGrpSpPr>
+        <p:cNvPr id="1" name=""/>
+        <p:cNvGrpSpPr/>
+        <p:nvPr/>
+      </p:nvGrpSpPr>
+      <p:grpSpPr/>
+      <p:sp>
+        <p:nvSpPr>
+          <p:cNvPr id="2" name="Rectangle 1"/>
+          <p:cNvSpPr/>
+          <p:nvPr/>
+        </p:nvSpPr>
+        <p:spPr>
+          <a:xfrm>
+            <a:off x="0" y="0"/>
+            <a:ext cx="12191695" cy="137160"/>
+          </a:xfrm>
+          <a:prstGeom prst="rect">
+            <a:avLst/>
+          </a:prstGeom>
+          <a:solidFill>
+            <a:srgbClr val="003080"/>
+          </a:solidFill>
+          <a:ln>
+            <a:noFill/>
+          </a:ln>
+        </p:spPr>
+        <p:style>
+          <a:lnRef idx="1">
+            <a:schemeClr val="accent1"/>
+          </a:lnRef>
+          <a:fillRef idx="3">
+            <a:schemeClr val="accent1"/>
+          </a:fillRef>
+          <a:effectRef idx="2">
+            <a:schemeClr val="accent1"/>
+          </a:effectRef>
+          <a:fontRef idx="minor">
+            <a:schemeClr val="lt1"/>
+          </a:fontRef>
+        </p:style>
+        <p:txBody>
+          <a:bodyPr rtlCol="0" anchor="ctr"/>
+          <a:lstStyle/>
+          <a:p>
+            <a:pPr algn="ctr"/>
+          </a:p>
+        </p:txBody>
+      </p:sp>
+      <p:sp>
+        <p:nvSpPr>
+          <p:cNvPr id="3" name="TextBox 2"/>
+          <p:cNvSpPr txBox="1"/>
+          <p:nvPr/>
+        </p:nvSpPr>
+        <p:spPr>
+          <a:xfrm>
+            <a:off x="685800" y="457200"/>
+            <a:ext cx="10820095" cy="914400"/>
+          </a:xfrm>
+          <a:prstGeom prst="rect">
+            <a:avLst/>
+          </a:prstGeom>
+          <a:noFill/>
+        </p:spPr>
+        <p:txBody>
+          <a:bodyPr wrap="none">
+            <a:spAutoFit/>
+          </a:bodyPr>
+          <a:lstStyle/>
+          <a:p>
+            <a:pPr>
+              <a:defRPr sz="4000" b="1">
+                <a:solidFill>
+                  <a:srgbClr val="003080"/>
+                </a:solidFill>
+              </a:defRPr>
+            </a:pPr>
+            <a:r>
+              <a:t>Upcoming Events</a:t>
+            </a:r>
+          </a:p>
+        </p:txBody>
+      </p:sp>
+      <p:sp>
+        <p:nvSpPr>
+          <p:cNvPr id="4" name="Rectangle 3"/>
+          <p:cNvSpPr/>
+          <p:nvPr/>
+        </p:nvSpPr>
+        <p:spPr>
+          <a:xfrm>
+            <a:off x="685800" y="1463040"/>
+            <a:ext cx="1188720" cy="914400"/>
+          </a:xfrm>
+          <a:prstGeom prst="rect">
+            <a:avLst/>
+          </a:prstGeom>
+          <a:solidFill>
+            <a:srgbClr val="003080"/>
+          </a:solidFill>
+          <a:ln>
+            <a:noFill/>
+          </a:ln>
+        </p:spPr>
+        <p:style>
+          <a:lnRef idx="1">
+            <a:schemeClr val="accent1"/>
+          </a:lnRef>
+          <a:fillRef idx="3">
+            <a:schemeClr val="accent1"/>
+          </a:fillRef>
+          <a:effectRef idx="2">
+            <a:schemeClr val="accent1"/>
+          </a:effectRef>
+          <a:fontRef idx="minor">
+            <a:schemeClr val="lt1"/>
+          </a:fontRef>
+        </p:style>
+        <p:txBody>
+          <a:bodyPr rtlCol="0" anchor="ctr"/>
+          <a:lstStyle/>
+          <a:p>
+            <a:pPr algn="ctr"/>
+          </a:p>
+        </p:txBody>
+      </p:sp>
+      <p:sp>
+        <p:nvSpPr>
+          <p:cNvPr id="5" name="TextBox 4"/>
+          <p:cNvSpPr txBox="1"/>
+          <p:nvPr/>
+        </p:nvSpPr>
+        <p:spPr>
+          <a:xfrm>
+            <a:off x="685800" y="1554480"/>
+            <a:ext cx="1188720" cy="731520"/>
+          </a:xfrm>
+          <a:prstGeom prst="rect">
+            <a:avLst/>
+          </a:prstGeom>
+          <a:noFill/>
+        </p:spPr>
+        <p:txBody>
+          <a:bodyPr wrap="none">
+            <a:spAutoFit/>
+          </a:bodyPr>
+          <a:lstStyle/>
+          <a:p>
+            <a:pPr algn="ctr">
+              <a:defRPr sz="1400" b="1">
+                <a:solidFill>
+                  <a:srgbClr val="FFFFFF"/>
+                </a:solidFill>
+              </a:defRPr>
+            </a:pPr>
+            <a:r>
+              <a:t>FEB</a:t>
+            </a:r>
+          </a:p>
+          <a:p>
+            <a:pPr algn="ctr">
+              <a:defRPr sz="2800" b="1">
+                <a:solidFill>
+                  <a:srgbClr val="FFFFFF"/>
+                </a:solidFill>
+              </a:defRPr>
+            </a:pPr>
+            <a:r>
+              <a:t>12</a:t>
+            </a:r>
+          </a:p>
+        </p:txBody>
+      </p:sp>
+      <p:sp>
+        <p:nvSpPr>
+          <p:cNvPr id="6" name="TextBox 5"/>
+          <p:cNvSpPr txBox="1"/>
+          <p:nvPr/>
+        </p:nvSpPr>
+        <p:spPr>
+          <a:xfrm>
+            <a:off x="2103120" y="1463040"/>
+            <a:ext cx="9144000" cy="914400"/>
+          </a:xfrm>
+          <a:prstGeom prst="rect">
+            <a:avLst/>
+          </a:prstGeom>
+          <a:noFill/>
+        </p:spPr>
+        <p:txBody>
+          <a:bodyPr wrap="none">
+            <a:spAutoFit/>
+          </a:bodyPr>
+          <a:lstStyle/>
+          <a:p>
+            <a:pPr>
+              <a:defRPr sz="1400" b="1">
+                <a:solidFill>
+                  <a:srgbClr val="DA770D"/>
+                </a:solidFill>
+              </a:defRPr>
+            </a:pPr>
+            <a:r>
+              <a:t>Webinar (Free)</a:t>
+            </a:r>
+          </a:p>
+          <a:p>
+            <a:pPr>
+              <a:defRPr sz="2200" b="1">
+                <a:solidFill>
+                  <a:srgbClr val="1C1C1C"/>
+                </a:solidFill>
+              </a:defRPr>
+            </a:pPr>
+            <a:r>
+              <a:t>Introduction to Health Economics</a:t>
+            </a:r>
+          </a:p>
+        </p:txBody>
+      </p:sp>
+      <p:sp>
+        <p:nvSpPr>
+          <p:cNvPr id="7" name="Rectangle 6"/>
+          <p:cNvSpPr/>
+          <p:nvPr/>
+        </p:nvSpPr>
+        <p:spPr>
+          <a:xfrm>
+            <a:off x="685800" y="2651760"/>
+            <a:ext cx="1188720" cy="914400"/>
+          </a:xfrm>
+          <a:prstGeom prst="rect">
+            <a:avLst/>
+          </a:prstGeom>
+          <a:solidFill>
+            <a:srgbClr val="003080"/>
+          </a:solidFill>
+          <a:ln>
+            <a:noFill/>
+          </a:ln>
+        </p:spPr>
+        <p:style>
+          <a:lnRef idx="1">
+            <a:schemeClr val="accent1"/>
+          </a:lnRef>
+          <a:fillRef idx="3">
+            <a:schemeClr val="accent1"/>
+          </a:fillRef>
+          <a:effectRef idx="2">
+            <a:schemeClr val="accent1"/>
+          </a:effectRef>
+          <a:fontRef idx="minor">
+            <a:schemeClr val="lt1"/>
+          </a:fontRef>
+        </p:style>
+        <p:txBody>
+          <a:bodyPr rtlCol="0" anchor="ctr"/>
+          <a:lstStyle/>
+          <a:p>
+            <a:pPr algn="ctr"/>
+          </a:p>
+        </p:txBody>
+      </p:sp>
+      <p:sp>
+        <p:nvSpPr>
+          <p:cNvPr id="8" name="TextBox 7"/>
+          <p:cNvSpPr txBox="1"/>
+          <p:nvPr/>
+        </p:nvSpPr>
+        <p:spPr>
+          <a:xfrm>
+            <a:off x="685800" y="2743200"/>
+            <a:ext cx="1188720" cy="731520"/>
+          </a:xfrm>
+          <a:prstGeom prst="rect">
+            <a:avLst/>
+          </a:prstGeom>
+          <a:noFill/>
+        </p:spPr>
+        <p:txBody>
+          <a:bodyPr wrap="none">
+            <a:spAutoFit/>
+          </a:bodyPr>
+          <a:lstStyle/>
+          <a:p>
+            <a:pPr algn="ctr">
+              <a:defRPr sz="1400" b="1">
+                <a:solidFill>
+                  <a:srgbClr val="FFFFFF"/>
+                </a:solidFill>
+              </a:defRPr>
+            </a:pPr>
+            <a:r>
+              <a:t>FEB</a:t>
+            </a:r>
+          </a:p>
+          <a:p>
+            <a:pPr algn="ctr">
+              <a:defRPr sz="2800" b="1">
+                <a:solidFill>
+                  <a:srgbClr val="FFFFFF"/>
+                </a:solidFill>
+              </a:defRPr>
+            </a:pPr>
+            <a:r>
+              <a:t>25</a:t>
+            </a:r>
+          </a:p>
+        </p:txBody>
+      </p:sp>
+      <p:sp>
+        <p:nvSpPr>
+          <p:cNvPr id="9" name="TextBox 8"/>
+          <p:cNvSpPr txBox="1"/>
+          <p:nvPr/>
+        </p:nvSpPr>
+        <p:spPr>
+          <a:xfrm>
+            <a:off x="2103120" y="2651760"/>
+            <a:ext cx="9144000" cy="914400"/>
+          </a:xfrm>
+          <a:prstGeom prst="rect">
+            <a:avLst/>
+          </a:prstGeom>
+          <a:noFill/>
+        </p:spPr>
+        <p:txBody>
+          <a:bodyPr wrap="none">
+            <a:spAutoFit/>
+          </a:bodyPr>
+          <a:lstStyle/>
+          <a:p>
+            <a:pPr>
+              <a:defRPr sz="1400" b="1">
+                <a:solidFill>
+                  <a:srgbClr val="DA770D"/>
+                </a:solidFill>
+              </a:defRPr>
+            </a:pPr>
+            <a:r>
+              <a:t>Peer Review</a:t>
+            </a:r>
+          </a:p>
+          <a:p>
+            <a:pPr>
+              <a:defRPr sz="2200" b="1">
+                <a:solidFill>
+                  <a:srgbClr val="1C1C1C"/>
+                </a:solidFill>
+              </a:defRPr>
+            </a:pPr>
+            <a:r>
+              <a:t>Monthly Member Meeting</a:t>
+            </a:r>
+          </a:p>
+        </p:txBody>
+      </p:sp>
+      <p:sp>
+        <p:nvSpPr>
+          <p:cNvPr id="10" name="Rectangle 9"/>
+          <p:cNvSpPr/>
+          <p:nvPr/>
+        </p:nvSpPr>
+        <p:spPr>
+          <a:xfrm>
+            <a:off x="685800" y="3840480"/>
+            <a:ext cx="1188720" cy="914400"/>
+          </a:xfrm>
+          <a:prstGeom prst="rect">
+            <a:avLst/>
+          </a:prstGeom>
+          <a:solidFill>
+            <a:srgbClr val="003080"/>
+          </a:solidFill>
+          <a:ln>
+            <a:noFill/>
+          </a:ln>
+        </p:spPr>
+        <p:style>
+          <a:lnRef idx="1">
+            <a:schemeClr val="accent1"/>
+          </a:lnRef>
+          <a:fillRef idx="3">
+            <a:schemeClr val="accent1"/>
+          </a:fillRef>
+          <a:effectRef idx="2">
+            <a:schemeClr val="accent1"/>
+          </a:effectRef>
+          <a:fontRef idx="minor">
+            <a:schemeClr val="lt1"/>
+          </a:fontRef>
+        </p:style>
+        <p:txBody>
+          <a:bodyPr rtlCol="0" anchor="ctr"/>
+          <a:lstStyle/>
+          <a:p>
+            <a:pPr algn="ctr"/>
+          </a:p>
+        </p:txBody>
+      </p:sp>
+      <p:sp>
+        <p:nvSpPr>
+          <p:cNvPr id="11" name="TextBox 10"/>
+          <p:cNvSpPr txBox="1"/>
+          <p:nvPr/>
+        </p:nvSpPr>
+        <p:spPr>
+          <a:xfrm>
+            <a:off x="685800" y="3931920"/>
+            <a:ext cx="1188720" cy="731520"/>
+          </a:xfrm>
+          <a:prstGeom prst="rect">
+            <a:avLst/>
+          </a:prstGeom>
+          <a:noFill/>
+        </p:spPr>
+        <p:txBody>
+          <a:bodyPr wrap="none">
+            <a:spAutoFit/>
+          </a:bodyPr>
+          <a:lstStyle/>
+          <a:p>
+            <a:pPr algn="ctr">
+              <a:defRPr sz="1400" b="1">
+                <a:solidFill>
+                  <a:srgbClr val="FFFFFF"/>
+                </a:solidFill>
+              </a:defRPr>
+            </a:pPr>
+            <a:r>
+              <a:t>MAR</a:t>
+            </a:r>
+          </a:p>
+          <a:p>
+            <a:pPr algn="ctr">
+              <a:defRPr sz="2800" b="1">
+                <a:solidFill>
+                  <a:srgbClr val="FFFFFF"/>
+                </a:solidFill>
+              </a:defRPr>
+            </a:pPr>
+            <a:r>
+              <a:t>25</a:t>
+            </a:r>
+          </a:p>
+        </p:txBody>
+      </p:sp>
+      <p:sp>
+        <p:nvSpPr>
+          <p:cNvPr id="12" name="TextBox 11"/>
+          <p:cNvSpPr txBox="1"/>
+          <p:nvPr/>
+        </p:nvSpPr>
+        <p:spPr>
+          <a:xfrm>
+            <a:off x="2103120" y="3840480"/>
+            <a:ext cx="9144000" cy="914400"/>
+          </a:xfrm>
+          <a:prstGeom prst="rect">
+            <a:avLst/>
+          </a:prstGeom>
+          <a:noFill/>
+        </p:spPr>
+        <p:txBody>
+          <a:bodyPr wrap="none">
+            <a:spAutoFit/>
+          </a:bodyPr>
+          <a:lstStyle/>
+          <a:p>
+            <a:pPr>
+              <a:defRPr sz="1400" b="1">
+                <a:solidFill>
+                  <a:srgbClr val="DA770D"/>
+                </a:solidFill>
+              </a:defRPr>
+            </a:pPr>
+            <a:r>
+              <a:t>Peer Review</a:t>
+            </a:r>
+          </a:p>
+          <a:p>
+            <a:pPr>
+              <a:defRPr sz="2200" b="1">
+                <a:solidFill>
+                  <a:srgbClr val="1C1C1C"/>
+                </a:solidFill>
+              </a:defRPr>
+            </a:pPr>
+            <a:r>
+              <a:t>Tim Brown: Public Health ROI</a:t>
+            </a:r>
+          </a:p>
+        </p:txBody>
+      </p:sp>
+      <p:sp>
+        <p:nvSpPr>
+          <p:cNvPr id="13" name="Rectangle 12"/>
+          <p:cNvSpPr/>
+          <p:nvPr/>
+        </p:nvSpPr>
+        <p:spPr>
+          <a:xfrm>
+            <a:off x="685800" y="5029200"/>
+            <a:ext cx="1188720" cy="914400"/>
+          </a:xfrm>
+          <a:prstGeom prst="rect">
+            <a:avLst/>
+          </a:prstGeom>
+          <a:solidFill>
+            <a:srgbClr val="003080"/>
+          </a:solidFill>
+          <a:ln>
+            <a:noFill/>
+          </a:ln>
+        </p:spPr>
+        <p:style>
+          <a:lnRef idx="1">
+            <a:schemeClr val="accent1"/>
+          </a:lnRef>
+          <a:fillRef idx="3">
+            <a:schemeClr val="accent1"/>
+          </a:fillRef>
+          <a:effectRef idx="2">
+            <a:schemeClr val="accent1"/>
+          </a:effectRef>
+          <a:fontRef idx="minor">
+            <a:schemeClr val="lt1"/>
+          </a:fontRef>
+        </p:style>
+        <p:txBody>
+          <a:bodyPr rtlCol="0" anchor="ctr"/>
+          <a:lstStyle/>
+          <a:p>
+            <a:pPr algn="ctr"/>
+          </a:p>
+        </p:txBody>
+      </p:sp>
+      <p:sp>
+        <p:nvSpPr>
+          <p:cNvPr id="14" name="TextBox 13"/>
+          <p:cNvSpPr txBox="1"/>
+          <p:nvPr/>
+        </p:nvSpPr>
+        <p:spPr>
+          <a:xfrm>
+            <a:off x="685800" y="5120640"/>
+            <a:ext cx="1188720" cy="731520"/>
+          </a:xfrm>
+          <a:prstGeom prst="rect">
+            <a:avLst/>
+          </a:prstGeom>
+          <a:noFill/>
+        </p:spPr>
+        <p:txBody>
+          <a:bodyPr wrap="none">
+            <a:spAutoFit/>
+          </a:bodyPr>
+          <a:lstStyle/>
+          <a:p>
+            <a:pPr algn="ctr">
+              <a:defRPr sz="1400" b="1">
+                <a:solidFill>
+                  <a:srgbClr val="FFFFFF"/>
+                </a:solidFill>
+              </a:defRPr>
+            </a:pPr>
+            <a:r>
+              <a:t>APR</a:t>
+            </a:r>
+          </a:p>
+          <a:p>
+            <a:pPr algn="ctr">
+              <a:defRPr sz="2800" b="1">
+                <a:solidFill>
+                  <a:srgbClr val="FFFFFF"/>
+                </a:solidFill>
+              </a:defRPr>
+            </a:pPr>
+            <a:r>
+              <a:t>09</a:t>
+            </a:r>
+          </a:p>
+        </p:txBody>
+      </p:sp>
+      <p:sp>
+        <p:nvSpPr>
+          <p:cNvPr id="15" name="TextBox 14"/>
+          <p:cNvSpPr txBox="1"/>
+          <p:nvPr/>
+        </p:nvSpPr>
+        <p:spPr>
+          <a:xfrm>
+            <a:off x="2103120" y="5029200"/>
+            <a:ext cx="9144000" cy="914400"/>
+          </a:xfrm>
+          <a:prstGeom prst="rect">
+            <a:avLst/>
+          </a:prstGeom>
+          <a:noFill/>
+        </p:spPr>
+        <p:txBody>
+          <a:bodyPr wrap="none">
+            <a:spAutoFit/>
+          </a:bodyPr>
+          <a:lstStyle/>
+          <a:p>
+            <a:pPr>
+              <a:defRPr sz="1400" b="1">
+                <a:solidFill>
+                  <a:srgbClr val="DA770D"/>
+                </a:solidFill>
+              </a:defRPr>
+            </a:pPr>
+            <a:r>
+              <a:t>Webinar (Free)</a:t>
+            </a:r>
+          </a:p>
+          <a:p>
+            <a:pPr>
+              <a:defRPr sz="2200" b="1">
+                <a:solidFill>
+                  <a:srgbClr val="1C1C1C"/>
+                </a:solidFill>
+              </a:defRPr>
+            </a:pPr>
+            <a:r>
+              <a:t>Cost-Effectiveness: The Basics</a:t>
+            </a:r>
+          </a:p>
+        </p:txBody>
+      </p:sp>
+    </p:spTree>
+  </p:cSld>
+  <p:clrMapOvr>
+    <a:masterClrMapping/>
+  </p:clrMapOvr>
+</p:sld>
+</file>
+
+<file path=ppt/slides/slide9.xml><?xml version="1.0" encoding="utf-8"?>
+<p:sld xmlns:a="http://schemas.openxmlformats.org/drawingml/2006/main" xmlns:p="http://schemas.openxmlformats.org/presentationml/2006/main" xmlns:r="http://schemas.openxmlformats.org/officeDocument/2006/relationships">
+  <p:cSld>
+    <p:spTree>
+      <p:nvGrpSpPr>
+        <p:cNvPr id="1" name=""/>
+        <p:cNvGrpSpPr/>
+        <p:nvPr/>
+      </p:nvGrpSpPr>
+      <p:grpSpPr/>
+      <p:sp>
+        <p:nvSpPr>
+          <p:cNvPr id="2" name="Rectangle 1"/>
+          <p:cNvSpPr/>
+          <p:nvPr/>
+        </p:nvSpPr>
+        <p:spPr>
+          <a:xfrm>
+            <a:off x="0" y="0"/>
+            <a:ext cx="12191695" cy="6858000"/>
+          </a:xfrm>
+          <a:prstGeom prst="rect">
+            <a:avLst/>
+          </a:prstGeom>
+          <a:solidFill>
+            <a:srgbClr val="003080"/>
+          </a:solidFill>
+          <a:ln>
+            <a:noFill/>
+          </a:ln>
+        </p:spPr>
+        <p:style>
+          <a:lnRef idx="1">
+            <a:schemeClr val="accent1"/>
+          </a:lnRef>
+          <a:fillRef idx="3">
+            <a:schemeClr val="accent1"/>
+          </a:fillRef>
+          <a:effectRef idx="2">
+            <a:schemeClr val="accent1"/>
+          </a:effectRef>
+          <a:fontRef idx="minor">
+            <a:schemeClr val="lt1"/>
+          </a:fontRef>
+        </p:style>
+        <p:txBody>
+          <a:bodyPr rtlCol="0" anchor="ctr"/>
+          <a:lstStyle/>
+          <a:p>
+            <a:pPr algn="ctr"/>
+          </a:p>
+        </p:txBody>
+      </p:sp>
+      <p:sp>
+        <p:nvSpPr>
+          <p:cNvPr id="3" name="TextBox 2"/>
+          <p:cNvSpPr txBox="1"/>
+          <p:nvPr/>
+        </p:nvSpPr>
+        <p:spPr>
+          <a:xfrm>
+            <a:off x="457200" y="2286000"/>
+            <a:ext cx="11277295" cy="914400"/>
+          </a:xfrm>
+          <a:prstGeom prst="rect">
+            <a:avLst/>
+          </a:prstGeom>
+          <a:noFill/>
+        </p:spPr>
+        <p:txBody>
+          <a:bodyPr wrap="none">
+            <a:spAutoFit/>
+          </a:bodyPr>
+          <a:lstStyle/>
+          <a:p>
+            <a:pPr algn="ctr">
+              <a:defRPr sz="6000" b="1">
+                <a:solidFill>
+                  <a:srgbClr val="FFFFFF"/>
+                </a:solidFill>
+              </a:defRPr>
+            </a:pPr>
+            <a:r>
+              <a:t>Thank You!</a:t>
+            </a:r>
+          </a:p>
+        </p:txBody>
+      </p:sp>
+      <p:sp>
+        <p:nvSpPr>
+          <p:cNvPr id="4" name="TextBox 3"/>
+          <p:cNvSpPr txBox="1"/>
+          <p:nvPr/>
+        </p:nvSpPr>
+        <p:spPr>
+          <a:xfrm>
+            <a:off x="457200" y="3429000"/>
+            <a:ext cx="11277295" cy="685800"/>
+          </a:xfrm>
+          <a:prstGeom prst="rect">
+            <a:avLst/>
+          </a:prstGeom>
+          <a:noFill/>
+        </p:spPr>
+        <p:txBody>
+          <a:bodyPr wrap="none">
+            <a:spAutoFit/>
+          </a:bodyPr>
+          <a:lstStyle/>
+          <a:p>
+            <a:pPr algn="ctr">
+              <a:defRPr sz="2400">
+                <a:solidFill>
+                  <a:srgbClr val="C8D7F0"/>
+                </a:solidFill>
+              </a:defRPr>
+            </a:pPr>
+            <a:r>
+              <a:t>Next Meeting: February 25, 2026</a:t>
+            </a:r>
+          </a:p>
+        </p:txBody>
+      </p:sp>
+      <p:sp>
+        <p:nvSpPr>
+          <p:cNvPr id="5" name="TextBox 4"/>
+          <p:cNvSpPr txBox="1"/>
+          <p:nvPr/>
+        </p:nvSpPr>
+        <p:spPr>
+          <a:xfrm>
+            <a:off x="457200" y="4343400"/>
+            <a:ext cx="11277295" cy="685800"/>
+          </a:xfrm>
+          <a:prstGeom prst="rect">
+            <a:avLst/>
+          </a:prstGeom>
+          <a:noFill/>
+        </p:spPr>
+        <p:txBody>
+          <a:bodyPr wrap="none">
+            <a:spAutoFit/>
+          </a:bodyPr>
+          <a:lstStyle/>
+          <a:p>
+            <a:pPr algn="ctr">
+              <a:defRPr sz="3200" b="1">
+                <a:solidFill>
+                  <a:srgbClr val="DA770D"/>
+                </a:solidFill>
+              </a:defRPr>
+            </a:pPr>
+            <a:r>
+              <a:t>caphegroup.org</a:t>
+            </a:r>
+          </a:p>
+        </p:txBody>
+      </p:sp>
+      <p:sp>
+        <p:nvSpPr>
+          <p:cNvPr id="6" name="TextBox 5"/>
+          <p:cNvSpPr txBox="1"/>
+          <p:nvPr/>
+        </p:nvSpPr>
+        <p:spPr>
+          <a:xfrm>
+            <a:off x="457200" y="5029200"/>
             <a:ext cx="11277295" cy="457200"/>
           </a:xfrm>
           <a:prstGeom prst="rect">

</xml_diff>